<commit_message>
chore(brand): hand-edited decks (M0/M1/M5/M7/M8) + fix template 'Halcyon layer'
Pushes the re-rendered .pptx (Halcyon/Halo -> Eiger/Iggy) and rebrands the
module-README template. NOTE: M4 Supply Chain.pptx still carries old branding
(not yet re-rendered).

Co-Authored-By: Claude Opus 4.8 <noreply@anthropic.com>
</commit_message>
<xml_diff>
--- a/blackhat-2026-adversarial-ai/M0-threat-model/slides/M0 - Introduction.pptx
+++ b/blackhat-2026-adversarial-ai/M0-threat-model/slides/M0 - Introduction.pptx
@@ -4,6 +4,9 @@
   <p:sldMasterIdLst>
     <p:sldMasterId id="2147483648" r:id="rId1"/>
   </p:sldMasterIdLst>
+  <p:notesMasterIdLst>
+    <p:notesMasterId r:id="rId16"/>
+  </p:notesMasterIdLst>
   <p:sldIdLst>
     <p:sldId id="256" r:id="rId2"/>
     <p:sldId id="257" r:id="rId3"/>
@@ -20,9 +23,6 @@
     <p:sldId id="268" r:id="rId14"/>
     <p:sldId id="269" r:id="rId15"/>
   </p:sldIdLst>
-  <p:notesMasterIdLst>
-    <p:notesMasterId r:id="rId16"/>
-  </p:notesMasterIdLst>
   <p:sldSz cx="18288000" cy="10287000"/>
   <p:notesSz cx="10287000" cy="18288000"/>
   <p:defaultTextStyle>
@@ -117,6 +117,11 @@
       </a:defRPr>
     </a:lvl9pPr>
   </p:defaultTextStyle>
+  <p:extLst>
+    <p:ext uri="{EFAFB233-063F-42B5-8137-9DF3F51BA10A}">
+      <p15:sldGuideLst xmlns:p15="http://schemas.microsoft.com/office/powerpoint/2012/main"/>
+    </p:ext>
+  </p:extLst>
 </p:presentation>
 </file>
 
@@ -142,234 +147,10 @@
           <a:chExt cx="0" cy="0"/>
         </a:xfrm>
       </p:grpSpPr>
-      <p:sp>
-        <p:nvSpPr>
-          <p:cNvPr id="2" name="Header Placeholder 1"/>
-          <p:cNvSpPr>
-            <a:spLocks noGrp="1"/>
-          </p:cNvSpPr>
-          <p:nvPr>
-            <p:ph type="hdr" sz="quarter"/>
-          </p:nvPr>
-        </p:nvSpPr>
-        <p:spPr>
-          <a:xfrm>
-            <a:off x="0" y="0"/>
-            <a:ext cx="2971800" cy="458788"/>
-          </a:xfrm>
-          <a:prstGeom prst="rect">
-            <a:avLst/>
-          </a:prstGeom>
-        </p:spPr>
-        <p:txBody>
-          <a:bodyPr vert="horz" lIns="91440" tIns="45720" rIns="91440" bIns="45720" rtlCol="0"/>
-          <a:lstStyle>
-            <a:lvl1pPr algn="l">
-              <a:defRPr sz="1200"/>
-            </a:lvl1pPr>
-          </a:lstStyle>
-          <a:p>
-            <a:endParaRPr lang="en-US"/>
-          </a:p>
-        </p:txBody>
-      </p:sp>
-      <p:sp>
-        <p:nvSpPr>
-          <p:cNvPr id="3" name="Date Placeholder 2"/>
-          <p:cNvSpPr>
-            <a:spLocks noGrp="1"/>
-          </p:cNvSpPr>
-          <p:nvPr>
-            <p:ph type="dt" idx="1"/>
-          </p:nvPr>
-        </p:nvSpPr>
-        <p:spPr>
-          <a:xfrm>
-            <a:off x="3884613" y="0"/>
-            <a:ext cx="2971800" cy="458788"/>
-          </a:xfrm>
-          <a:prstGeom prst="rect">
-            <a:avLst/>
-          </a:prstGeom>
-        </p:spPr>
-        <p:txBody>
-          <a:bodyPr vert="horz" lIns="91440" tIns="45720" rIns="91440" bIns="45720" rtlCol="0"/>
-          <a:lstStyle>
-            <a:lvl1pPr algn="r">
-              <a:defRPr sz="1200"/>
-            </a:lvl1pPr>
-          </a:lstStyle>
-          <a:p>
-            <a:fld id="{5282F153-3F37-0F45-9E97-73ACFA13230C}" type="datetimeFigureOut">
-              <a:rPr lang="en-US"/>
-              <a:t>7/23/19</a:t>
-            </a:fld>
-            <a:endParaRPr lang="en-US"/>
-          </a:p>
-        </p:txBody>
-      </p:sp>
-      <p:sp>
-        <p:nvSpPr>
-          <p:cNvPr id="4" name="Slide Image Placeholder 3"/>
-          <p:cNvSpPr>
-            <a:spLocks noGrp="1" noRot="1" noChangeAspect="1"/>
-          </p:cNvSpPr>
-          <p:nvPr>
-            <p:ph type="sldImg" idx="2"/>
-          </p:nvPr>
-        </p:nvSpPr>
-        <p:spPr>
-          <a:xfrm>
-            <a:off x="685800" y="1143000"/>
-            <a:ext cx="5486400" cy="3086100"/>
-          </a:xfrm>
-          <a:prstGeom prst="rect">
-            <a:avLst/>
-          </a:prstGeom>
-          <a:noFill/>
-          <a:ln w="12700">
-            <a:solidFill>
-              <a:prstClr val="black"/>
-            </a:solidFill>
-          </a:ln>
-        </p:spPr>
-        <p:txBody>
-          <a:bodyPr vert="horz" lIns="91440" tIns="45720" rIns="91440" bIns="45720" rtlCol="0" anchor="ctr"/>
-          <a:lstStyle/>
-          <a:p>
-            <a:endParaRPr lang="en-US"/>
-          </a:p>
-        </p:txBody>
-      </p:sp>
-      <p:sp>
-        <p:nvSpPr>
-          <p:cNvPr id="5" name="Notes Placeholder 4"/>
-          <p:cNvSpPr>
-            <a:spLocks noGrp="1"/>
-          </p:cNvSpPr>
-          <p:nvPr>
-            <p:ph type="body" sz="quarter" idx="3"/>
-          </p:nvPr>
-        </p:nvSpPr>
-        <p:spPr>
-          <a:xfrm>
-            <a:off x="685800" y="4400550"/>
-            <a:ext cx="5486400" cy="3600450"/>
-          </a:xfrm>
-          <a:prstGeom prst="rect">
-            <a:avLst/>
-          </a:prstGeom>
-        </p:spPr>
-        <p:txBody>
-          <a:bodyPr vert="horz" lIns="91440" tIns="45720" rIns="91440" bIns="45720" rtlCol="0"/>
-          <a:lstStyle/>
-          <a:p>
-            <a:pPr lvl="0"/>
-            <a:r>
-              <a:rPr lang="en-US"/>
-              <a:t>Click to edit Master text styles</a:t>
-            </a:r>
-          </a:p>
-          <a:p>
-            <a:pPr lvl="1"/>
-            <a:r>
-              <a:rPr lang="en-US"/>
-              <a:t>Second level</a:t>
-            </a:r>
-          </a:p>
-          <a:p>
-            <a:pPr lvl="2"/>
-            <a:r>
-              <a:rPr lang="en-US"/>
-              <a:t>Third level</a:t>
-            </a:r>
-          </a:p>
-          <a:p>
-            <a:pPr lvl="3"/>
-            <a:r>
-              <a:rPr lang="en-US"/>
-              <a:t>Fourth level</a:t>
-            </a:r>
-          </a:p>
-          <a:p>
-            <a:pPr lvl="4"/>
-            <a:r>
-              <a:rPr lang="en-US"/>
-              <a:t>Fifth level</a:t>
-            </a:r>
-          </a:p>
-        </p:txBody>
-      </p:sp>
-      <p:sp>
-        <p:nvSpPr>
-          <p:cNvPr id="6" name="Footer Placeholder 5"/>
-          <p:cNvSpPr>
-            <a:spLocks noGrp="1"/>
-          </p:cNvSpPr>
-          <p:nvPr>
-            <p:ph type="ftr" sz="quarter" idx="4"/>
-          </p:nvPr>
-        </p:nvSpPr>
-        <p:spPr>
-          <a:xfrm>
-            <a:off x="0" y="8685213"/>
-            <a:ext cx="2971800" cy="458787"/>
-          </a:xfrm>
-          <a:prstGeom prst="rect">
-            <a:avLst/>
-          </a:prstGeom>
-        </p:spPr>
-        <p:txBody>
-          <a:bodyPr vert="horz" lIns="91440" tIns="45720" rIns="91440" bIns="45720" rtlCol="0" anchor="b"/>
-          <a:lstStyle>
-            <a:lvl1pPr algn="l">
-              <a:defRPr sz="1200"/>
-            </a:lvl1pPr>
-          </a:lstStyle>
-          <a:p>
-            <a:endParaRPr lang="en-US"/>
-          </a:p>
-        </p:txBody>
-      </p:sp>
-      <p:sp>
-        <p:nvSpPr>
-          <p:cNvPr id="7" name="Slide Number Placeholder 6"/>
-          <p:cNvSpPr>
-            <a:spLocks noGrp="1"/>
-          </p:cNvSpPr>
-          <p:nvPr>
-            <p:ph type="sldNum" sz="quarter" idx="5"/>
-          </p:nvPr>
-        </p:nvSpPr>
-        <p:spPr>
-          <a:xfrm>
-            <a:off x="3884613" y="8685213"/>
-            <a:ext cx="2971800" cy="458787"/>
-          </a:xfrm>
-          <a:prstGeom prst="rect">
-            <a:avLst/>
-          </a:prstGeom>
-        </p:spPr>
-        <p:txBody>
-          <a:bodyPr vert="horz" lIns="91440" tIns="45720" rIns="91440" bIns="45720" rtlCol="0" anchor="b"/>
-          <a:lstStyle>
-            <a:lvl1pPr algn="r">
-              <a:defRPr sz="1200"/>
-            </a:lvl1pPr>
-          </a:lstStyle>
-          <a:p>
-            <a:fld id="{CE5E9CC1-C706-0F49-92D6-E571CC5EEA8F}" type="slidenum">
-              <a:rPr lang="en-US"/>
-              <a:t>‹#›</a:t>
-            </a:fld>
-            <a:endParaRPr lang="en-US"/>
-          </a:p>
-        </p:txBody>
-      </p:sp>
     </p:spTree>
     <p:extLst>
       <p:ext uri="{BB962C8B-B14F-4D97-AF65-F5344CB8AC3E}">
-        <p14:creationId xmlns:p14="http://schemas.microsoft.com/office/powerpoint/2010/main" val="1024086991"/>
+        <p14:creationId xmlns:p14="http://schemas.microsoft.com/office/powerpoint/2010/main" val="4060581542"/>
       </p:ext>
     </p:extLst>
   </p:cSld>
@@ -517,7 +298,6 @@
               <a:rPr lang="en-US" dirty="0"/>
               <a:t>Black Hat title slide. Welcome them. Two days, one target, hands-on. Set the tone: you will spend most of this course with your hands on a keyboard attacking a live system, not watching slides.</a:t>
             </a:r>
-            <a:endParaRPr lang="en-US" dirty="0"/>
           </a:p>
         </p:txBody>
       </p:sp>
@@ -605,7 +385,6 @@
               <a:rPr lang="en-US" dirty="0"/>
               <a:t>Everyone runs the reach-test now: it confirms you can reach Halcyon, your browser routes through Burp with the cert trusted, and your key is valid. Green in about 60 seconds. This is where we catch proxy and cert problems. Anyone red, flag it — we fix it while the rest warm up on Gandalf.</a:t>
             </a:r>
-            <a:endParaRPr lang="en-US" dirty="0"/>
           </a:p>
         </p:txBody>
       </p:sp>
@@ -693,7 +472,6 @@
               <a:rPr lang="en-US" dirty="0"/>
               <a:t>Send them to gandalf.lakera.ai — browser only, no setup. Levels 1 to 3 as a group. Zero-stakes first taste of prompt injection, and it gives stragglers cover to finish their Burp setup. Foreshadows M1.</a:t>
             </a:r>
-            <a:endParaRPr lang="en-US" dirty="0"/>
           </a:p>
         </p:txBody>
       </p:sp>
@@ -781,7 +559,6 @@
               <a:rPr lang="en-US" dirty="0"/>
               <a:t>The one idea to carry all week. Find the boundary where data crosses into instruction, own the system.</a:t>
             </a:r>
-            <a:endParaRPr lang="en-US" dirty="0"/>
           </a:p>
         </p:txBody>
       </p:sp>
@@ -869,7 +646,6 @@
               <a:rPr lang="en-US" dirty="0"/>
               <a:t>Transition. We start where the attacker input meets the model directly.</a:t>
             </a:r>
-            <a:endParaRPr lang="en-US" dirty="0"/>
           </a:p>
         </p:txBody>
       </p:sp>
@@ -957,7 +733,6 @@
               <a:rPr lang="en-US" dirty="0"/>
               <a:t>Black Hat end slide. Hand off to M1.</a:t>
             </a:r>
-            <a:endParaRPr lang="en-US" dirty="0"/>
           </a:p>
         </p:txBody>
       </p:sp>
@@ -1045,7 +820,6 @@
               <a:rPr lang="en-US" dirty="0"/>
               <a:t>Section divider. This first hour does three things: get everyone connected and green, install the mental model for the whole course, and warm up on a hosted target while stragglers finish setup.</a:t>
             </a:r>
-            <a:endParaRPr lang="en-US" dirty="0"/>
           </a:p>
         </p:txBody>
       </p:sp>
@@ -1133,7 +907,6 @@
               <a:rPr lang="en-US" dirty="0"/>
               <a:t>This is the rhythm for all 8 modules. The diff between vulnerable and secure IS the lesson.</a:t>
             </a:r>
-            <a:endParaRPr lang="en-US" dirty="0"/>
           </a:p>
         </p:txBody>
       </p:sp>
@@ -1221,7 +994,6 @@
               <a:rPr lang="en-US" dirty="0"/>
               <a:t>The core reframe. People come in thinking prompt injection is the topic. Real systems are a chain of components, each trusting the last. We attack the chain, in order.</a:t>
             </a:r>
-            <a:endParaRPr lang="en-US" dirty="0"/>
           </a:p>
         </p:txBody>
       </p:sp>
@@ -1309,7 +1081,6 @@
               <a:rPr lang="en-US" dirty="0"/>
               <a:t>One map, not two: the same six words drive the Halo table next. We do not teach OWASP as a checklist. We walk the chain and the vulnerabilities appear where they actually occur. Mirrors a real engagement.</a:t>
             </a:r>
-            <a:endParaRPr lang="en-US" dirty="0"/>
           </a:p>
         </p:txBody>
       </p:sp>
@@ -1397,7 +1168,6 @@
               <a:rPr lang="en-US" dirty="0"/>
               <a:t>One company for two days. Because it is a bank, every exploit has concrete impact. Not abstract.</a:t>
             </a:r>
-            <a:endParaRPr lang="en-US" dirty="0"/>
           </a:p>
         </p:txBody>
       </p:sp>
@@ -1485,7 +1255,6 @@
               <a:rPr lang="en-US" dirty="0"/>
               <a:t>Same assistant, more surface each time. Layer names match the spine slide exactly. Build this table one row per module as the course progresses. Do not dwell — they will live each row.</a:t>
             </a:r>
-            <a:endParaRPr lang="en-US" dirty="0"/>
           </a:p>
         </p:txBody>
       </p:sp>
@@ -1573,7 +1342,6 @@
               <a:rPr lang="en-US" dirty="0"/>
               <a:t>Critical, and reassuring. We never grade on the model’s words. Every objective is validated by a mechanism query. This is why the labs are reliable and repeatable.</a:t>
             </a:r>
-            <a:endParaRPr lang="en-US" dirty="0"/>
           </a:p>
         </p:txBody>
       </p:sp>
@@ -1661,7 +1429,6 @@
               <a:rPr lang="en-US" dirty="0"/>
               <a:t>No difficulty ladder — a floor and a ceiling. Day 1 is keyless on a shared model we host. Day 2 uses your own API key. Aside: the flag model is granular under the hood, a couple of modules flip more than one, but vulnerable to secure is the mental model.</a:t>
             </a:r>
-            <a:endParaRPr lang="en-US" dirty="0"/>
           </a:p>
         </p:txBody>
       </p:sp>
@@ -1734,6 +1501,11 @@
 <file path=ppt/slideMasters/slideMaster1.xml><?xml version="1.0" encoding="utf-8"?>
 <p:sldMaster xmlns:a="http://schemas.openxmlformats.org/drawingml/2006/main" xmlns:r="http://schemas.openxmlformats.org/officeDocument/2006/relationships" xmlns:p="http://schemas.openxmlformats.org/presentationml/2006/main">
   <p:cSld>
+    <p:bg>
+      <p:bgRef idx="1001">
+        <a:schemeClr val="bg1"/>
+      </p:bgRef>
+    </p:bg>
     <p:spTree>
       <p:nvGrpSpPr>
         <p:cNvPr id="1" name=""/>
@@ -2016,6 +1788,7 @@
         <a:solidFill>
           <a:srgbClr val="000000"/>
         </a:solidFill>
+        <a:effectLst/>
       </p:bgPr>
     </p:bg>
     <p:spTree>
@@ -2073,17 +1846,24 @@
           </a:gradFill>
           <a:ln/>
         </p:spPr>
+        <p:txBody>
+          <a:bodyPr/>
+          <a:lstStyle/>
+          <a:p>
+            <a:endParaRPr lang="en-US"/>
+          </a:p>
+        </p:txBody>
       </p:sp>
       <p:pic>
         <p:nvPicPr>
-          <p:cNvPr id="3" name="Image 0" descr="preencoded.png">    </p:cNvPr>
+          <p:cNvPr id="3" name="Image 0" descr="preencoded.png"/>
           <p:cNvPicPr>
             <a:picLocks noChangeAspect="1"/>
           </p:cNvPicPr>
           <p:nvPr/>
         </p:nvPicPr>
         <p:blipFill>
-          <a:blip r:embed="rId1"/>
+          <a:blip r:embed="rId3"/>
           <a:stretch>
             <a:fillRect/>
           </a:stretch>
@@ -2121,11 +1901,11 @@
           </a:bodyPr>
           <a:lstStyle/>
           <a:p>
-            <a:pPr algn="l" indent="0" marL="0">
-              <a:buNone/>
-            </a:pPr>
-            <a:r>
-              <a:rPr lang="en-US" sz="1650" spc="495" kern="0" dirty="0">
+            <a:pPr marL="0" indent="0" algn="l">
+              <a:buNone/>
+            </a:pPr>
+            <a:r>
+              <a:rPr lang="en-US" sz="1650" kern="0" spc="495" dirty="0">
                 <a:solidFill>
                   <a:srgbClr val="36CDFF"/>
                 </a:solidFill>
@@ -2162,14 +1942,14 @@
           </a:bodyPr>
           <a:lstStyle/>
           <a:p>
-            <a:pPr algn="l" indent="0" marL="0">
+            <a:pPr marL="0" indent="0" algn="l">
               <a:lnSpc>
                 <a:spcPct val="72174"/>
               </a:lnSpc>
               <a:buNone/>
             </a:pPr>
             <a:r>
-              <a:rPr lang="en-US" sz="12750" b="1" spc="127" kern="0" dirty="0">
+              <a:rPr lang="en-US" sz="12750" b="1" kern="0" spc="127" dirty="0">
                 <a:solidFill>
                   <a:srgbClr val="FFFFFF"/>
                 </a:solidFill>
@@ -2179,14 +1959,8 @@
               </a:rPr>
               <a:t>ADVERSARIAL </a:t>
             </a:r>
-            <a:pPr algn="l" indent="0" marL="0">
-              <a:lnSpc>
-                <a:spcPct val="72174"/>
-              </a:lnSpc>
-              <a:buNone/>
-            </a:pPr>
-            <a:r>
-              <a:rPr lang="en-US" sz="12750" b="1" spc="127" kern="0" dirty="0">
+            <a:r>
+              <a:rPr lang="en-US" sz="12750" b="1" kern="0" spc="127" dirty="0">
                 <a:solidFill>
                   <a:srgbClr val="FD7EF5"/>
                 </a:solidFill>
@@ -2223,7 +1997,7 @@
           </a:bodyPr>
           <a:lstStyle/>
           <a:p>
-            <a:pPr algn="l" indent="0" marL="0">
+            <a:pPr marL="0" indent="0" algn="l">
               <a:lnSpc>
                 <a:spcPct val="121739"/>
               </a:lnSpc>
@@ -2246,14 +2020,14 @@
       </p:sp>
       <p:pic>
         <p:nvPicPr>
-          <p:cNvPr id="7" name="Image 1" descr="preencoded.png">    </p:cNvPr>
+          <p:cNvPr id="7" name="Image 1" descr="preencoded.png"/>
           <p:cNvPicPr>
             <a:picLocks noChangeAspect="1"/>
           </p:cNvPicPr>
           <p:nvPr/>
         </p:nvPicPr>
         <p:blipFill>
-          <a:blip r:embed="rId2"/>
+          <a:blip r:embed="rId4"/>
           <a:stretch>
             <a:fillRect/>
           </a:stretch>
@@ -2291,14 +2065,14 @@
           </a:bodyPr>
           <a:lstStyle/>
           <a:p>
-            <a:pPr algn="r" indent="0" marL="0">
+            <a:pPr marL="0" indent="0" algn="r">
               <a:lnSpc>
                 <a:spcPct val="152105"/>
               </a:lnSpc>
               <a:buNone/>
             </a:pPr>
             <a:r>
-              <a:rPr lang="en-US" sz="1275" spc="179" kern="0" dirty="0">
+              <a:rPr lang="en-US" sz="1275" kern="0" spc="179" dirty="0">
                 <a:solidFill>
                   <a:srgbClr val="FFFFFF"/>
                 </a:solidFill>
@@ -2335,14 +2109,14 @@
           </a:bodyPr>
           <a:lstStyle/>
           <a:p>
-            <a:pPr algn="r" indent="0" marL="0">
+            <a:pPr marL="0" indent="0" algn="r">
               <a:lnSpc>
                 <a:spcPct val="152105"/>
               </a:lnSpc>
               <a:buNone/>
             </a:pPr>
             <a:r>
-              <a:rPr lang="en-US" sz="1275" spc="179" kern="0" dirty="0">
+              <a:rPr lang="en-US" sz="1275" kern="0" spc="179" dirty="0">
                 <a:solidFill>
                   <a:srgbClr val="969696"/>
                 </a:solidFill>
@@ -2372,6 +2146,7 @@
         <a:solidFill>
           <a:srgbClr val="000000"/>
         </a:solidFill>
+        <a:effectLst/>
       </p:bgPr>
     </p:bg>
     <p:spTree>
@@ -2407,6 +2182,13 @@
           </a:solidFill>
           <a:ln/>
         </p:spPr>
+        <p:txBody>
+          <a:bodyPr/>
+          <a:lstStyle/>
+          <a:p>
+            <a:endParaRPr lang="en-US"/>
+          </a:p>
+        </p:txBody>
       </p:sp>
       <p:sp>
         <p:nvSpPr>
@@ -2431,11 +2213,11 @@
           </a:bodyPr>
           <a:lstStyle/>
           <a:p>
-            <a:pPr algn="l" indent="0" marL="0">
-              <a:buNone/>
-            </a:pPr>
-            <a:r>
-              <a:rPr lang="en-US" sz="1950" spc="663" kern="0" dirty="0">
+            <a:pPr marL="0" indent="0" algn="l">
+              <a:buNone/>
+            </a:pPr>
+            <a:r>
+              <a:rPr lang="en-US" sz="1950" kern="0" spc="663" dirty="0">
                 <a:solidFill>
                   <a:srgbClr val="FD7EF5"/>
                 </a:solidFill>
@@ -2472,7 +2254,7 @@
           </a:bodyPr>
           <a:lstStyle/>
           <a:p>
-            <a:pPr algn="l" indent="0" marL="0">
+            <a:pPr marL="0" indent="0" algn="l">
               <a:lnSpc>
                 <a:spcPct val="71304"/>
               </a:lnSpc>
@@ -2516,7 +2298,7 @@
           </a:bodyPr>
           <a:lstStyle/>
           <a:p>
-            <a:pPr algn="l" indent="0" marL="0">
+            <a:pPr marL="0" indent="0" algn="l">
               <a:lnSpc>
                 <a:spcPct val="122051"/>
               </a:lnSpc>
@@ -2533,12 +2315,6 @@
               </a:rPr>
               <a:t>Reach-test: </a:t>
             </a:r>
-            <a:pPr algn="l" indent="0" marL="0">
-              <a:lnSpc>
-                <a:spcPct val="122051"/>
-              </a:lnSpc>
-              <a:buNone/>
-            </a:pPr>
             <a:r>
               <a:rPr lang="en-US" sz="2550" b="1" dirty="0">
                 <a:solidFill>
@@ -2556,14 +2332,14 @@
       </p:sp>
       <p:pic>
         <p:nvPicPr>
-          <p:cNvPr id="6" name="Image 0" descr="preencoded.png">    </p:cNvPr>
+          <p:cNvPr id="6" name="Image 0" descr="preencoded.png"/>
           <p:cNvPicPr>
             <a:picLocks noChangeAspect="1"/>
           </p:cNvPicPr>
           <p:nvPr/>
         </p:nvPicPr>
         <p:blipFill>
-          <a:blip r:embed="rId1"/>
+          <a:blip r:embed="rId3"/>
           <a:stretch>
             <a:fillRect/>
           </a:stretch>
@@ -2601,11 +2377,11 @@
           </a:bodyPr>
           <a:lstStyle/>
           <a:p>
-            <a:pPr algn="l" indent="0" marL="0">
-              <a:buNone/>
-            </a:pPr>
-            <a:r>
-              <a:rPr lang="en-US" sz="1200" spc="264" kern="0" dirty="0">
+            <a:pPr marL="0" indent="0" algn="l">
+              <a:buNone/>
+            </a:pPr>
+            <a:r>
+              <a:rPr lang="en-US" sz="1200" kern="0" spc="264" dirty="0">
                 <a:solidFill>
                   <a:srgbClr val="969696"/>
                 </a:solidFill>
@@ -2635,6 +2411,7 @@
         <a:solidFill>
           <a:srgbClr val="000000"/>
         </a:solidFill>
+        <a:effectLst/>
       </p:bgPr>
     </p:bg>
     <p:spTree>
@@ -2670,6 +2447,13 @@
           </a:solidFill>
           <a:ln/>
         </p:spPr>
+        <p:txBody>
+          <a:bodyPr/>
+          <a:lstStyle/>
+          <a:p>
+            <a:endParaRPr lang="en-US"/>
+          </a:p>
+        </p:txBody>
       </p:sp>
       <p:sp>
         <p:nvSpPr>
@@ -2694,11 +2478,11 @@
           </a:bodyPr>
           <a:lstStyle/>
           <a:p>
-            <a:pPr algn="l" indent="0" marL="0">
-              <a:buNone/>
-            </a:pPr>
-            <a:r>
-              <a:rPr lang="en-US" sz="1950" spc="663" kern="0" dirty="0">
+            <a:pPr marL="0" indent="0" algn="l">
+              <a:buNone/>
+            </a:pPr>
+            <a:r>
+              <a:rPr lang="en-US" sz="1950" kern="0" spc="663" dirty="0">
                 <a:solidFill>
                   <a:srgbClr val="36CDFF"/>
                 </a:solidFill>
@@ -2735,7 +2519,7 @@
           </a:bodyPr>
           <a:lstStyle/>
           <a:p>
-            <a:pPr algn="l" indent="0" marL="0">
+            <a:pPr marL="0" indent="0" algn="l">
               <a:lnSpc>
                 <a:spcPct val="71446"/>
               </a:lnSpc>
@@ -2779,7 +2563,7 @@
           </a:bodyPr>
           <a:lstStyle/>
           <a:p>
-            <a:pPr algn="l" indent="0" marL="0">
+            <a:pPr marL="0" indent="0" algn="l">
               <a:lnSpc>
                 <a:spcPct val="122051"/>
               </a:lnSpc>
@@ -2802,14 +2586,14 @@
       </p:sp>
       <p:pic>
         <p:nvPicPr>
-          <p:cNvPr id="6" name="Image 0" descr="preencoded.png">    </p:cNvPr>
+          <p:cNvPr id="6" name="Image 0" descr="preencoded.png"/>
           <p:cNvPicPr>
             <a:picLocks noChangeAspect="1"/>
           </p:cNvPicPr>
           <p:nvPr/>
         </p:nvPicPr>
         <p:blipFill>
-          <a:blip r:embed="rId1"/>
+          <a:blip r:embed="rId3"/>
           <a:stretch>
             <a:fillRect/>
           </a:stretch>
@@ -2847,11 +2631,11 @@
           </a:bodyPr>
           <a:lstStyle/>
           <a:p>
-            <a:pPr algn="l" indent="0" marL="0">
-              <a:buNone/>
-            </a:pPr>
-            <a:r>
-              <a:rPr lang="en-US" sz="1200" spc="264" kern="0" dirty="0">
+            <a:pPr marL="0" indent="0" algn="l">
+              <a:buNone/>
+            </a:pPr>
+            <a:r>
+              <a:rPr lang="en-US" sz="1200" kern="0" spc="264" dirty="0">
                 <a:solidFill>
                   <a:srgbClr val="969696"/>
                 </a:solidFill>
@@ -2881,6 +2665,7 @@
         <a:solidFill>
           <a:srgbClr val="000000"/>
         </a:solidFill>
+        <a:effectLst/>
       </p:bgPr>
     </p:bg>
     <p:spTree>
@@ -2920,11 +2705,11 @@
           </a:bodyPr>
           <a:lstStyle/>
           <a:p>
-            <a:pPr algn="l" indent="0" marL="0">
-              <a:buNone/>
-            </a:pPr>
-            <a:r>
-              <a:rPr lang="en-US" sz="1650" spc="495" kern="0" dirty="0">
+            <a:pPr marL="0" indent="0" algn="l">
+              <a:buNone/>
+            </a:pPr>
+            <a:r>
+              <a:rPr lang="en-US" sz="1650" kern="0" spc="495" dirty="0">
                 <a:solidFill>
                   <a:srgbClr val="FD7EF5"/>
                 </a:solidFill>
@@ -2961,7 +2746,7 @@
           </a:bodyPr>
           <a:lstStyle/>
           <a:p>
-            <a:pPr algn="l" indent="0" marL="0">
+            <a:pPr marL="0" indent="0" algn="l">
               <a:lnSpc>
                 <a:spcPct val="78113"/>
               </a:lnSpc>
@@ -2978,12 +2763,6 @@
               </a:rPr>
               <a:t>YOU’RE NOT PROMPTING. YOU’RE SUPPLYING </a:t>
             </a:r>
-            <a:pPr algn="l" indent="0" marL="0">
-              <a:lnSpc>
-                <a:spcPct val="78113"/>
-              </a:lnSpc>
-              <a:buNone/>
-            </a:pPr>
             <a:r>
               <a:rPr lang="en-US" sz="6900" dirty="0">
                 <a:solidFill>
@@ -3022,7 +2801,7 @@
           </a:bodyPr>
           <a:lstStyle/>
           <a:p>
-            <a:pPr algn="l" indent="0" marL="0">
+            <a:pPr marL="0" indent="0" algn="l">
               <a:lnSpc>
                 <a:spcPct val="126087"/>
               </a:lnSpc>
@@ -3045,14 +2824,14 @@
       </p:sp>
       <p:pic>
         <p:nvPicPr>
-          <p:cNvPr id="5" name="Image 0" descr="preencoded.png">    </p:cNvPr>
+          <p:cNvPr id="5" name="Image 0" descr="preencoded.png"/>
           <p:cNvPicPr>
             <a:picLocks noChangeAspect="1"/>
           </p:cNvPicPr>
           <p:nvPr/>
         </p:nvPicPr>
         <p:blipFill>
-          <a:blip r:embed="rId1"/>
+          <a:blip r:embed="rId3"/>
           <a:stretch>
             <a:fillRect/>
           </a:stretch>
@@ -3090,11 +2869,11 @@
           </a:bodyPr>
           <a:lstStyle/>
           <a:p>
-            <a:pPr algn="l" indent="0" marL="0">
-              <a:buNone/>
-            </a:pPr>
-            <a:r>
-              <a:rPr lang="en-US" sz="1200" spc="264" kern="0" dirty="0">
+            <a:pPr marL="0" indent="0" algn="l">
+              <a:buNone/>
+            </a:pPr>
+            <a:r>
+              <a:rPr lang="en-US" sz="1200" kern="0" spc="264" dirty="0">
                 <a:solidFill>
                   <a:srgbClr val="969696"/>
                 </a:solidFill>
@@ -3124,6 +2903,7 @@
         <a:solidFill>
           <a:srgbClr val="000000"/>
         </a:solidFill>
+        <a:effectLst/>
       </p:bgPr>
     </p:bg>
     <p:spTree>
@@ -3163,11 +2943,11 @@
           </a:bodyPr>
           <a:lstStyle/>
           <a:p>
-            <a:pPr algn="l" indent="0" marL="0">
-              <a:buNone/>
-            </a:pPr>
-            <a:r>
-              <a:rPr lang="en-US" sz="1500" spc="450" kern="0" dirty="0">
+            <a:pPr marL="0" indent="0" algn="l">
+              <a:buNone/>
+            </a:pPr>
+            <a:r>
+              <a:rPr lang="en-US" sz="1500" kern="0" spc="450" dirty="0">
                 <a:solidFill>
                   <a:srgbClr val="36CDFF"/>
                 </a:solidFill>
@@ -3204,7 +2984,7 @@
           </a:bodyPr>
           <a:lstStyle/>
           <a:p>
-            <a:pPr algn="l" indent="0" marL="0">
+            <a:pPr marL="0" indent="0" algn="l">
               <a:lnSpc>
                 <a:spcPct val="72832"/>
               </a:lnSpc>
@@ -3248,7 +3028,7 @@
           </a:bodyPr>
           <a:lstStyle/>
           <a:p>
-            <a:pPr algn="l" indent="0" marL="0">
+            <a:pPr marL="0" indent="0" algn="l">
               <a:lnSpc>
                 <a:spcPct val="126410"/>
               </a:lnSpc>
@@ -3292,7 +3072,7 @@
           </a:bodyPr>
           <a:lstStyle/>
           <a:p>
-            <a:pPr algn="l" indent="0" marL="0">
+            <a:pPr marL="0" indent="0" algn="l">
               <a:lnSpc>
                 <a:spcPct val="125522"/>
               </a:lnSpc>
@@ -3307,7 +3087,7 @@
                 <a:ea typeface="Arial" pitchFamily="34" charset="-122"/>
                 <a:cs typeface="Arial" pitchFamily="34" charset="-120"/>
               </a:rPr>
-              <a:t>We start where the attacker’s input meets the model directly — extract a secret Halo was explicitly told to guard.</a:t>
+              <a:t>We start where the attacker’s input meets the model directly — extract a secret Iggy was explicitly told to guard.</a:t>
             </a:r>
             <a:endParaRPr lang="en-US" sz="2175" dirty="0"/>
           </a:p>
@@ -3315,14 +3095,14 @@
       </p:sp>
       <p:pic>
         <p:nvPicPr>
-          <p:cNvPr id="6" name="Image 0" descr="preencoded.png">    </p:cNvPr>
+          <p:cNvPr id="6" name="Image 0" descr="preencoded.png"/>
           <p:cNvPicPr>
             <a:picLocks noChangeAspect="1"/>
           </p:cNvPicPr>
           <p:nvPr/>
         </p:nvPicPr>
         <p:blipFill>
-          <a:blip r:embed="rId1"/>
+          <a:blip r:embed="rId3"/>
           <a:stretch>
             <a:fillRect/>
           </a:stretch>
@@ -3360,11 +3140,11 @@
           </a:bodyPr>
           <a:lstStyle/>
           <a:p>
-            <a:pPr algn="l" indent="0" marL="0">
-              <a:buNone/>
-            </a:pPr>
-            <a:r>
-              <a:rPr lang="en-US" sz="1200" spc="264" kern="0" dirty="0">
+            <a:pPr marL="0" indent="0" algn="l">
+              <a:buNone/>
+            </a:pPr>
+            <a:r>
+              <a:rPr lang="en-US" sz="1200" kern="0" spc="264" dirty="0">
                 <a:solidFill>
                   <a:srgbClr val="969696"/>
                 </a:solidFill>
@@ -3394,6 +3174,7 @@
         <a:solidFill>
           <a:srgbClr val="000000"/>
         </a:solidFill>
+        <a:effectLst/>
       </p:bgPr>
     </p:bg>
     <p:spTree>
@@ -3433,11 +3214,11 @@
           </a:bodyPr>
           <a:lstStyle/>
           <a:p>
-            <a:pPr algn="l" indent="0" marL="0">
-              <a:buNone/>
-            </a:pPr>
-            <a:r>
-              <a:rPr lang="en-US" sz="1650" spc="495" kern="0" dirty="0">
+            <a:pPr marL="0" indent="0" algn="l">
+              <a:buNone/>
+            </a:pPr>
+            <a:r>
+              <a:rPr lang="en-US" sz="1650" kern="0" spc="495" dirty="0">
                 <a:solidFill>
                   <a:srgbClr val="36CDFF"/>
                 </a:solidFill>
@@ -3474,7 +3255,7 @@
           </a:bodyPr>
           <a:lstStyle/>
           <a:p>
-            <a:pPr algn="l" indent="0" marL="0">
+            <a:pPr marL="0" indent="0" algn="l">
               <a:lnSpc>
                 <a:spcPct val="69565"/>
               </a:lnSpc>
@@ -3491,12 +3272,6 @@
               </a:rPr>
               <a:t>M0</a:t>
             </a:r>
-            <a:pPr algn="l" indent="0" marL="0">
-              <a:lnSpc>
-                <a:spcPct val="69565"/>
-              </a:lnSpc>
-              <a:buNone/>
-            </a:pPr>
             <a:r>
               <a:rPr lang="en-US" sz="22500" b="1" dirty="0">
                 <a:solidFill>
@@ -3535,7 +3310,7 @@
           </a:bodyPr>
           <a:lstStyle/>
           <a:p>
-            <a:pPr algn="l" indent="0" marL="0">
+            <a:pPr marL="0" indent="0" algn="l">
               <a:lnSpc>
                 <a:spcPct val="126410"/>
               </a:lnSpc>
@@ -3558,14 +3333,14 @@
       </p:sp>
       <p:pic>
         <p:nvPicPr>
-          <p:cNvPr id="5" name="Image 0" descr="preencoded.png">    </p:cNvPr>
+          <p:cNvPr id="5" name="Image 0" descr="preencoded.png"/>
           <p:cNvPicPr>
             <a:picLocks noChangeAspect="1"/>
           </p:cNvPicPr>
           <p:nvPr/>
         </p:nvPicPr>
         <p:blipFill>
-          <a:blip r:embed="rId1"/>
+          <a:blip r:embed="rId3"/>
           <a:stretch>
             <a:fillRect/>
           </a:stretch>
@@ -3603,11 +3378,11 @@
           </a:bodyPr>
           <a:lstStyle/>
           <a:p>
-            <a:pPr algn="l" indent="0" marL="0">
-              <a:buNone/>
-            </a:pPr>
-            <a:r>
-              <a:rPr lang="en-US" sz="1200" spc="264" kern="0" dirty="0">
+            <a:pPr marL="0" indent="0" algn="l">
+              <a:buNone/>
+            </a:pPr>
+            <a:r>
+              <a:rPr lang="en-US" sz="1200" kern="0" spc="264" dirty="0">
                 <a:solidFill>
                   <a:srgbClr val="969696"/>
                 </a:solidFill>
@@ -3637,6 +3412,7 @@
         <a:solidFill>
           <a:srgbClr val="000000"/>
         </a:solidFill>
+        <a:effectLst/>
       </p:bgPr>
     </p:bg>
     <p:spTree>
@@ -3672,6 +3448,13 @@
           </a:solidFill>
           <a:ln/>
         </p:spPr>
+        <p:txBody>
+          <a:bodyPr/>
+          <a:lstStyle/>
+          <a:p>
+            <a:endParaRPr lang="en-US"/>
+          </a:p>
+        </p:txBody>
       </p:sp>
       <p:sp>
         <p:nvSpPr>
@@ -3696,11 +3479,11 @@
           </a:bodyPr>
           <a:lstStyle/>
           <a:p>
-            <a:pPr algn="l" indent="0" marL="0">
-              <a:buNone/>
-            </a:pPr>
-            <a:r>
-              <a:rPr lang="en-US" sz="1950" spc="663" kern="0" dirty="0">
+            <a:pPr marL="0" indent="0" algn="l">
+              <a:buNone/>
+            </a:pPr>
+            <a:r>
+              <a:rPr lang="en-US" sz="1950" kern="0" spc="663" dirty="0">
                 <a:solidFill>
                   <a:srgbClr val="36CDFF"/>
                 </a:solidFill>
@@ -3737,7 +3520,7 @@
           </a:bodyPr>
           <a:lstStyle/>
           <a:p>
-            <a:pPr algn="l" indent="0" marL="0">
+            <a:pPr marL="0" indent="0" algn="l">
               <a:lnSpc>
                 <a:spcPct val="71304"/>
               </a:lnSpc>
@@ -3781,7 +3564,7 @@
           </a:bodyPr>
           <a:lstStyle/>
           <a:p>
-            <a:pPr algn="l" indent="0" marL="0">
+            <a:pPr marL="0" indent="0" algn="l">
               <a:lnSpc>
                 <a:spcPct val="122051"/>
               </a:lnSpc>
@@ -3804,14 +3587,14 @@
       </p:sp>
       <p:pic>
         <p:nvPicPr>
-          <p:cNvPr id="6" name="Image 0" descr="preencoded.png">    </p:cNvPr>
+          <p:cNvPr id="6" name="Image 0" descr="preencoded.png"/>
           <p:cNvPicPr>
             <a:picLocks noChangeAspect="1"/>
           </p:cNvPicPr>
           <p:nvPr/>
         </p:nvPicPr>
         <p:blipFill>
-          <a:blip r:embed="rId1"/>
+          <a:blip r:embed="rId3"/>
           <a:stretch>
             <a:fillRect/>
           </a:stretch>
@@ -3849,11 +3632,11 @@
           </a:bodyPr>
           <a:lstStyle/>
           <a:p>
-            <a:pPr algn="l" indent="0" marL="0">
-              <a:buNone/>
-            </a:pPr>
-            <a:r>
-              <a:rPr lang="en-US" sz="1200" spc="264" kern="0" dirty="0">
+            <a:pPr marL="0" indent="0" algn="l">
+              <a:buNone/>
+            </a:pPr>
+            <a:r>
+              <a:rPr lang="en-US" sz="1200" kern="0" spc="264" dirty="0">
                 <a:solidFill>
                   <a:srgbClr val="969696"/>
                 </a:solidFill>
@@ -3883,6 +3666,7 @@
         <a:solidFill>
           <a:srgbClr val="000000"/>
         </a:solidFill>
+        <a:effectLst/>
       </p:bgPr>
     </p:bg>
     <p:spTree>
@@ -3922,11 +3706,11 @@
           </a:bodyPr>
           <a:lstStyle/>
           <a:p>
-            <a:pPr algn="l" indent="0" marL="0">
-              <a:buNone/>
-            </a:pPr>
-            <a:r>
-              <a:rPr lang="en-US" sz="1500" spc="450" kern="0" dirty="0">
+            <a:pPr marL="0" indent="0" algn="l">
+              <a:buNone/>
+            </a:pPr>
+            <a:r>
+              <a:rPr lang="en-US" sz="1500" kern="0" spc="450" dirty="0">
                 <a:solidFill>
                   <a:srgbClr val="36CDFF"/>
                 </a:solidFill>
@@ -3963,7 +3747,7 @@
           </a:bodyPr>
           <a:lstStyle/>
           <a:p>
-            <a:pPr algn="l" indent="0" marL="0">
+            <a:pPr marL="0" indent="0" algn="l">
               <a:lnSpc>
                 <a:spcPct val="73043"/>
               </a:lnSpc>
@@ -4007,7 +3791,7 @@
           </a:bodyPr>
           <a:lstStyle/>
           <a:p>
-            <a:pPr algn="l" indent="0" marL="0">
+            <a:pPr marL="0" indent="0" algn="l">
               <a:lnSpc>
                 <a:spcPct val="126410"/>
               </a:lnSpc>
@@ -4024,12 +3808,6 @@
               </a:rPr>
               <a:t>Two days. One target. Three verbs — </a:t>
             </a:r>
-            <a:pPr algn="l" indent="0" marL="0">
-              <a:lnSpc>
-                <a:spcPct val="126410"/>
-              </a:lnSpc>
-              <a:buNone/>
-            </a:pPr>
             <a:r>
               <a:rPr lang="en-US" sz="2550" b="1" dirty="0">
                 <a:solidFill>
@@ -4068,7 +3846,7 @@
           </a:bodyPr>
           <a:lstStyle/>
           <a:p>
-            <a:pPr algn="l" indent="0" marL="0">
+            <a:pPr marL="0" indent="0" algn="l">
               <a:lnSpc>
                 <a:spcPct val="125522"/>
               </a:lnSpc>
@@ -4091,14 +3869,14 @@
       </p:sp>
       <p:pic>
         <p:nvPicPr>
-          <p:cNvPr id="6" name="Image 0" descr="preencoded.png">    </p:cNvPr>
+          <p:cNvPr id="6" name="Image 0" descr="preencoded.png"/>
           <p:cNvPicPr>
             <a:picLocks noChangeAspect="1"/>
           </p:cNvPicPr>
           <p:nvPr/>
         </p:nvPicPr>
         <p:blipFill>
-          <a:blip r:embed="rId1"/>
+          <a:blip r:embed="rId3"/>
           <a:stretch>
             <a:fillRect/>
           </a:stretch>
@@ -4136,11 +3914,11 @@
           </a:bodyPr>
           <a:lstStyle/>
           <a:p>
-            <a:pPr algn="l" indent="0" marL="0">
-              <a:buNone/>
-            </a:pPr>
-            <a:r>
-              <a:rPr lang="en-US" sz="1200" spc="264" kern="0" dirty="0">
+            <a:pPr marL="0" indent="0" algn="l">
+              <a:buNone/>
+            </a:pPr>
+            <a:r>
+              <a:rPr lang="en-US" sz="1200" kern="0" spc="264" dirty="0">
                 <a:solidFill>
                   <a:srgbClr val="969696"/>
                 </a:solidFill>
@@ -4170,6 +3948,7 @@
         <a:solidFill>
           <a:srgbClr val="000000"/>
         </a:solidFill>
+        <a:effectLst/>
       </p:bgPr>
     </p:bg>
     <p:spTree>
@@ -4209,11 +3988,11 @@
           </a:bodyPr>
           <a:lstStyle/>
           <a:p>
-            <a:pPr algn="l" indent="0" marL="0">
-              <a:buNone/>
-            </a:pPr>
-            <a:r>
-              <a:rPr lang="en-US" sz="1650" spc="495" kern="0" dirty="0">
+            <a:pPr marL="0" indent="0" algn="l">
+              <a:buNone/>
+            </a:pPr>
+            <a:r>
+              <a:rPr lang="en-US" sz="1650" kern="0" spc="495" dirty="0">
                 <a:solidFill>
                   <a:srgbClr val="FD7EF5"/>
                 </a:solidFill>
@@ -4250,7 +4029,7 @@
           </a:bodyPr>
           <a:lstStyle/>
           <a:p>
-            <a:pPr algn="l" indent="0" marL="0">
+            <a:pPr marL="0" indent="0" algn="l">
               <a:lnSpc>
                 <a:spcPct val="78326"/>
               </a:lnSpc>
@@ -4267,12 +4046,6 @@
               </a:rPr>
               <a:t>AI ISN’T ONE THING YOU ATTACK. IT’S A </a:t>
             </a:r>
-            <a:pPr algn="l" indent="0" marL="0">
-              <a:lnSpc>
-                <a:spcPct val="78326"/>
-              </a:lnSpc>
-              <a:buNone/>
-            </a:pPr>
             <a:r>
               <a:rPr lang="en-US" sz="7800" dirty="0">
                 <a:solidFill>
@@ -4311,7 +4084,7 @@
           </a:bodyPr>
           <a:lstStyle/>
           <a:p>
-            <a:pPr algn="l" indent="0" marL="0">
+            <a:pPr marL="0" indent="0" algn="l">
               <a:lnSpc>
                 <a:spcPct val="126087"/>
               </a:lnSpc>
@@ -4334,14 +4107,14 @@
       </p:sp>
       <p:pic>
         <p:nvPicPr>
-          <p:cNvPr id="5" name="Image 0" descr="preencoded.png">    </p:cNvPr>
+          <p:cNvPr id="5" name="Image 0" descr="preencoded.png"/>
           <p:cNvPicPr>
             <a:picLocks noChangeAspect="1"/>
           </p:cNvPicPr>
           <p:nvPr/>
         </p:nvPicPr>
         <p:blipFill>
-          <a:blip r:embed="rId1"/>
+          <a:blip r:embed="rId3"/>
           <a:stretch>
             <a:fillRect/>
           </a:stretch>
@@ -4379,11 +4152,11 @@
           </a:bodyPr>
           <a:lstStyle/>
           <a:p>
-            <a:pPr algn="l" indent="0" marL="0">
-              <a:buNone/>
-            </a:pPr>
-            <a:r>
-              <a:rPr lang="en-US" sz="1200" spc="264" kern="0" dirty="0">
+            <a:pPr marL="0" indent="0" algn="l">
+              <a:buNone/>
+            </a:pPr>
+            <a:r>
+              <a:rPr lang="en-US" sz="1200" kern="0" spc="264" dirty="0">
                 <a:solidFill>
                   <a:srgbClr val="969696"/>
                 </a:solidFill>
@@ -4413,6 +4186,7 @@
         <a:solidFill>
           <a:srgbClr val="000000"/>
         </a:solidFill>
+        <a:effectLst/>
       </p:bgPr>
     </p:bg>
     <p:spTree>
@@ -4452,11 +4226,11 @@
           </a:bodyPr>
           <a:lstStyle/>
           <a:p>
-            <a:pPr algn="l" indent="0" marL="0">
-              <a:buNone/>
-            </a:pPr>
-            <a:r>
-              <a:rPr lang="en-US" sz="1500" spc="450" kern="0" dirty="0">
+            <a:pPr marL="0" indent="0" algn="l">
+              <a:buNone/>
+            </a:pPr>
+            <a:r>
+              <a:rPr lang="en-US" sz="1500" kern="0" spc="450" dirty="0">
                 <a:solidFill>
                   <a:srgbClr val="36CDFF"/>
                 </a:solidFill>
@@ -4493,7 +4267,7 @@
           </a:bodyPr>
           <a:lstStyle/>
           <a:p>
-            <a:pPr algn="l" indent="0" marL="0">
+            <a:pPr marL="0" indent="0" algn="l">
               <a:lnSpc>
                 <a:spcPct val="78113"/>
               </a:lnSpc>
@@ -4539,6 +4313,13 @@
             <a:prstDash val="solid"/>
           </a:ln>
         </p:spPr>
+        <p:txBody>
+          <a:bodyPr/>
+          <a:lstStyle/>
+          <a:p>
+            <a:endParaRPr lang="en-US"/>
+          </a:p>
+        </p:txBody>
       </p:sp>
       <p:sp>
         <p:nvSpPr>
@@ -4563,7 +4344,7 @@
           </a:bodyPr>
           <a:lstStyle/>
           <a:p>
-            <a:pPr algn="ctr" indent="0" marL="0">
+            <a:pPr marL="0" indent="0" algn="ctr">
               <a:buNone/>
             </a:pPr>
             <a:r>
@@ -4604,7 +4385,7 @@
           </a:bodyPr>
           <a:lstStyle/>
           <a:p>
-            <a:pPr algn="l" indent="0" marL="0">
+            <a:pPr marL="0" indent="0" algn="l">
               <a:buNone/>
             </a:pPr>
             <a:r>
@@ -4647,6 +4428,13 @@
             <a:prstDash val="solid"/>
           </a:ln>
         </p:spPr>
+        <p:txBody>
+          <a:bodyPr/>
+          <a:lstStyle/>
+          <a:p>
+            <a:endParaRPr lang="en-US"/>
+          </a:p>
+        </p:txBody>
       </p:sp>
       <p:sp>
         <p:nvSpPr>
@@ -4671,7 +4459,7 @@
           </a:bodyPr>
           <a:lstStyle/>
           <a:p>
-            <a:pPr algn="ctr" indent="0" marL="0">
+            <a:pPr marL="0" indent="0" algn="ctr">
               <a:buNone/>
             </a:pPr>
             <a:r>
@@ -4712,7 +4500,7 @@
           </a:bodyPr>
           <a:lstStyle/>
           <a:p>
-            <a:pPr algn="l" indent="0" marL="0">
+            <a:pPr marL="0" indent="0" algn="l">
               <a:buNone/>
             </a:pPr>
             <a:r>
@@ -4755,6 +4543,13 @@
             <a:prstDash val="solid"/>
           </a:ln>
         </p:spPr>
+        <p:txBody>
+          <a:bodyPr/>
+          <a:lstStyle/>
+          <a:p>
+            <a:endParaRPr lang="en-US"/>
+          </a:p>
+        </p:txBody>
       </p:sp>
       <p:sp>
         <p:nvSpPr>
@@ -4779,7 +4574,7 @@
           </a:bodyPr>
           <a:lstStyle/>
           <a:p>
-            <a:pPr algn="ctr" indent="0" marL="0">
+            <a:pPr marL="0" indent="0" algn="ctr">
               <a:buNone/>
             </a:pPr>
             <a:r>
@@ -4820,7 +4615,7 @@
           </a:bodyPr>
           <a:lstStyle/>
           <a:p>
-            <a:pPr algn="l" indent="0" marL="0">
+            <a:pPr marL="0" indent="0" algn="l">
               <a:buNone/>
             </a:pPr>
             <a:r>
@@ -4863,6 +4658,13 @@
             <a:prstDash val="solid"/>
           </a:ln>
         </p:spPr>
+        <p:txBody>
+          <a:bodyPr/>
+          <a:lstStyle/>
+          <a:p>
+            <a:endParaRPr lang="en-US"/>
+          </a:p>
+        </p:txBody>
       </p:sp>
       <p:sp>
         <p:nvSpPr>
@@ -4887,7 +4689,7 @@
           </a:bodyPr>
           <a:lstStyle/>
           <a:p>
-            <a:pPr algn="ctr" indent="0" marL="0">
+            <a:pPr marL="0" indent="0" algn="ctr">
               <a:buNone/>
             </a:pPr>
             <a:r>
@@ -4928,7 +4730,7 @@
           </a:bodyPr>
           <a:lstStyle/>
           <a:p>
-            <a:pPr algn="l" indent="0" marL="0">
+            <a:pPr marL="0" indent="0" algn="l">
               <a:buNone/>
             </a:pPr>
             <a:r>
@@ -4971,6 +4773,13 @@
             <a:prstDash val="solid"/>
           </a:ln>
         </p:spPr>
+        <p:txBody>
+          <a:bodyPr/>
+          <a:lstStyle/>
+          <a:p>
+            <a:endParaRPr lang="en-US"/>
+          </a:p>
+        </p:txBody>
       </p:sp>
       <p:sp>
         <p:nvSpPr>
@@ -4995,7 +4804,7 @@
           </a:bodyPr>
           <a:lstStyle/>
           <a:p>
-            <a:pPr algn="ctr" indent="0" marL="0">
+            <a:pPr marL="0" indent="0" algn="ctr">
               <a:buNone/>
             </a:pPr>
             <a:r>
@@ -5036,7 +4845,7 @@
           </a:bodyPr>
           <a:lstStyle/>
           <a:p>
-            <a:pPr algn="l" indent="0" marL="0">
+            <a:pPr marL="0" indent="0" algn="l">
               <a:buNone/>
             </a:pPr>
             <a:r>
@@ -5079,6 +4888,13 @@
             <a:prstDash val="solid"/>
           </a:ln>
         </p:spPr>
+        <p:txBody>
+          <a:bodyPr/>
+          <a:lstStyle/>
+          <a:p>
+            <a:endParaRPr lang="en-US"/>
+          </a:p>
+        </p:txBody>
       </p:sp>
       <p:sp>
         <p:nvSpPr>
@@ -5103,7 +4919,7 @@
           </a:bodyPr>
           <a:lstStyle/>
           <a:p>
-            <a:pPr algn="ctr" indent="0" marL="0">
+            <a:pPr marL="0" indent="0" algn="ctr">
               <a:buNone/>
             </a:pPr>
             <a:r>
@@ -5144,7 +4960,7 @@
           </a:bodyPr>
           <a:lstStyle/>
           <a:p>
-            <a:pPr algn="l" indent="0" marL="0">
+            <a:pPr marL="0" indent="0" algn="l">
               <a:lnSpc>
                 <a:spcPct val="126410"/>
               </a:lnSpc>
@@ -5161,12 +4977,6 @@
               </a:rPr>
               <a:t>Each layer adds attack surface. The OWASP LLM Top 10 lands </a:t>
             </a:r>
-            <a:pPr algn="l" indent="0" marL="0">
-              <a:lnSpc>
-                <a:spcPct val="126410"/>
-              </a:lnSpc>
-              <a:buNone/>
-            </a:pPr>
             <a:r>
               <a:rPr lang="en-US" sz="2550" b="1" dirty="0">
                 <a:solidFill>
@@ -5178,12 +4988,6 @@
               </a:rPr>
               <a:t>where it lives </a:t>
             </a:r>
-            <a:pPr algn="l" indent="0" marL="0">
-              <a:lnSpc>
-                <a:spcPct val="126410"/>
-              </a:lnSpc>
-              <a:buNone/>
-            </a:pPr>
             <a:r>
               <a:rPr lang="en-US" sz="2550" dirty="0">
                 <a:solidFill>
@@ -5201,14 +5005,14 @@
       </p:sp>
       <p:pic>
         <p:nvPicPr>
-          <p:cNvPr id="22" name="Image 0" descr="preencoded.png">    </p:cNvPr>
+          <p:cNvPr id="22" name="Image 0" descr="preencoded.png"/>
           <p:cNvPicPr>
             <a:picLocks noChangeAspect="1"/>
           </p:cNvPicPr>
           <p:nvPr/>
         </p:nvPicPr>
         <p:blipFill>
-          <a:blip r:embed="rId1"/>
+          <a:blip r:embed="rId3"/>
           <a:stretch>
             <a:fillRect/>
           </a:stretch>
@@ -5246,11 +5050,11 @@
           </a:bodyPr>
           <a:lstStyle/>
           <a:p>
-            <a:pPr algn="l" indent="0" marL="0">
-              <a:buNone/>
-            </a:pPr>
-            <a:r>
-              <a:rPr lang="en-US" sz="1200" spc="264" kern="0" dirty="0">
+            <a:pPr marL="0" indent="0" algn="l">
+              <a:buNone/>
+            </a:pPr>
+            <a:r>
+              <a:rPr lang="en-US" sz="1200" kern="0" spc="264" dirty="0">
                 <a:solidFill>
                   <a:srgbClr val="969696"/>
                 </a:solidFill>
@@ -5280,6 +5084,7 @@
         <a:solidFill>
           <a:srgbClr val="000000"/>
         </a:solidFill>
+        <a:effectLst/>
       </p:bgPr>
     </p:bg>
     <p:spTree>
@@ -5319,11 +5124,11 @@
           </a:bodyPr>
           <a:lstStyle/>
           <a:p>
-            <a:pPr algn="l" indent="0" marL="0">
-              <a:buNone/>
-            </a:pPr>
-            <a:r>
-              <a:rPr lang="en-US" sz="1500" spc="450" kern="0" dirty="0">
+            <a:pPr marL="0" indent="0" algn="l">
+              <a:buNone/>
+            </a:pPr>
+            <a:r>
+              <a:rPr lang="en-US" sz="1500" kern="0" spc="450" dirty="0">
                 <a:solidFill>
                   <a:srgbClr val="36CDFF"/>
                 </a:solidFill>
@@ -5356,11 +5161,11 @@
         </p:spPr>
         <p:txBody>
           <a:bodyPr wrap="square" lIns="25400" tIns="25400" rIns="25400" bIns="25400" rtlCol="0" anchor="t">
-            <a:normAutofit/>
-          </a:bodyPr>
-          <a:lstStyle/>
-          <a:p>
-            <a:pPr algn="l" indent="0" marL="0">
+            <a:normAutofit lnSpcReduction="10000"/>
+          </a:bodyPr>
+          <a:lstStyle/>
+          <a:p>
+            <a:pPr marL="0" indent="0" algn="l">
               <a:lnSpc>
                 <a:spcPct val="78113"/>
               </a:lnSpc>
@@ -5377,12 +5182,6 @@
               </a:rPr>
               <a:t>MEET THE TARGET: </a:t>
             </a:r>
-            <a:pPr algn="l" indent="0" marL="0">
-              <a:lnSpc>
-                <a:spcPct val="78113"/>
-              </a:lnSpc>
-              <a:buNone/>
-            </a:pPr>
             <a:r>
               <a:rPr lang="en-US" sz="6900" b="1" dirty="0">
                 <a:solidFill>
@@ -5392,7 +5191,7 @@
                 <a:ea typeface="Arial" pitchFamily="34" charset="-122"/>
                 <a:cs typeface="Arial" pitchFamily="34" charset="-120"/>
               </a:rPr>
-              <a:t>HALCYON</a:t>
+              <a:t>EIGER</a:t>
             </a:r>
             <a:endParaRPr lang="en-US" sz="6900" dirty="0"/>
           </a:p>
@@ -5421,7 +5220,7 @@
           </a:bodyPr>
           <a:lstStyle/>
           <a:p>
-            <a:pPr algn="l" indent="0" marL="0">
+            <a:pPr marL="0" indent="0" algn="l">
               <a:lnSpc>
                 <a:spcPct val="123795"/>
               </a:lnSpc>
@@ -5438,12 +5237,6 @@
               </a:rPr>
               <a:t>An AI-first </a:t>
             </a:r>
-            <a:pPr algn="l" indent="0" marL="0">
-              <a:lnSpc>
-                <a:spcPct val="123795"/>
-              </a:lnSpc>
-              <a:buNone/>
-            </a:pPr>
             <a:r>
               <a:rPr lang="en-US" sz="2550" b="1" dirty="0">
                 <a:solidFill>
@@ -5455,12 +5248,6 @@
               </a:rPr>
               <a:t>neobank. </a:t>
             </a:r>
-            <a:pPr algn="l" indent="0" marL="0">
-              <a:lnSpc>
-                <a:spcPct val="123795"/>
-              </a:lnSpc>
-              <a:buNone/>
-            </a:pPr>
             <a:r>
               <a:rPr lang="en-US" sz="2550" dirty="0">
                 <a:solidFill>
@@ -5472,12 +5259,6 @@
               </a:rPr>
               <a:t>Its assistant is </a:t>
             </a:r>
-            <a:pPr algn="l" indent="0" marL="0">
-              <a:lnSpc>
-                <a:spcPct val="123795"/>
-              </a:lnSpc>
-              <a:buNone/>
-            </a:pPr>
             <a:r>
               <a:rPr lang="en-US" sz="2550" b="1" dirty="0">
                 <a:solidFill>
@@ -5487,7 +5268,7 @@
                 <a:ea typeface="Arial" pitchFamily="34" charset="-122"/>
                 <a:cs typeface="Arial" pitchFamily="34" charset="-120"/>
               </a:rPr>
-              <a:t>Halo.</a:t>
+              <a:t>Iggy.</a:t>
             </a:r>
             <a:endParaRPr lang="en-US" sz="2550" dirty="0"/>
           </a:p>
@@ -5516,7 +5297,7 @@
           </a:bodyPr>
           <a:lstStyle/>
           <a:p>
-            <a:pPr algn="l" indent="0" marL="0">
+            <a:pPr marL="0" indent="0" algn="l">
               <a:lnSpc>
                 <a:spcPct val="125522"/>
               </a:lnSpc>
@@ -5558,6 +5339,13 @@
           </a:solidFill>
           <a:ln/>
         </p:spPr>
+        <p:txBody>
+          <a:bodyPr/>
+          <a:lstStyle/>
+          <a:p>
+            <a:endParaRPr lang="en-US"/>
+          </a:p>
+        </p:txBody>
       </p:sp>
       <p:sp>
         <p:nvSpPr>
@@ -5580,6 +5368,13 @@
           </a:solidFill>
           <a:ln/>
         </p:spPr>
+        <p:txBody>
+          <a:bodyPr/>
+          <a:lstStyle/>
+          <a:p>
+            <a:endParaRPr lang="en-US"/>
+          </a:p>
+        </p:txBody>
       </p:sp>
       <p:sp>
         <p:nvSpPr>
@@ -5600,6 +5395,13 @@
           </a:solidFill>
           <a:ln/>
         </p:spPr>
+        <p:txBody>
+          <a:bodyPr/>
+          <a:lstStyle/>
+          <a:p>
+            <a:endParaRPr lang="en-US"/>
+          </a:p>
+        </p:txBody>
       </p:sp>
       <p:sp>
         <p:nvSpPr>
@@ -5622,6 +5424,13 @@
           </a:solidFill>
           <a:ln/>
         </p:spPr>
+        <p:txBody>
+          <a:bodyPr/>
+          <a:lstStyle/>
+          <a:p>
+            <a:endParaRPr lang="en-US"/>
+          </a:p>
+        </p:txBody>
       </p:sp>
       <p:sp>
         <p:nvSpPr>
@@ -5646,11 +5455,11 @@
           </a:bodyPr>
           <a:lstStyle/>
           <a:p>
-            <a:pPr algn="l" indent="0" marL="0">
-              <a:buNone/>
-            </a:pPr>
-            <a:r>
-              <a:rPr lang="en-US" sz="1200" spc="192" kern="0" dirty="0">
+            <a:pPr marL="0" indent="0" algn="l">
+              <a:buNone/>
+            </a:pPr>
+            <a:r>
+              <a:rPr lang="en-US" sz="1200" kern="0" spc="192" dirty="0">
                 <a:solidFill>
                   <a:srgbClr val="FD7EF5"/>
                 </a:solidFill>
@@ -5687,7 +5496,7 @@
           </a:bodyPr>
           <a:lstStyle/>
           <a:p>
-            <a:pPr algn="l" indent="0" marL="0">
+            <a:pPr marL="0" indent="0" algn="l">
               <a:lnSpc>
                 <a:spcPct val="130645"/>
               </a:lnSpc>
@@ -5702,7 +5511,29 @@
                 <a:ea typeface="Arial" pitchFamily="34" charset="-122"/>
                 <a:cs typeface="Arial" pitchFamily="34" charset="-120"/>
               </a:rPr>
-              <a:t>One company for two days. You pwn Halcyon end to end — leak a secret, move money, approve a fraudulent dispute. Nothing abstract.</a:t>
+              <a:t>One company for two days. You </a:t>
+            </a:r>
+            <a:r>
+              <a:rPr lang="en-US" sz="2025" dirty="0" err="1">
+                <a:solidFill>
+                  <a:srgbClr val="C8C8C8"/>
+                </a:solidFill>
+                <a:latin typeface="Arial" pitchFamily="34" charset="0"/>
+                <a:ea typeface="Arial" pitchFamily="34" charset="-122"/>
+                <a:cs typeface="Arial" pitchFamily="34" charset="-120"/>
+              </a:rPr>
+              <a:t>pwn</a:t>
+            </a:r>
+            <a:r>
+              <a:rPr lang="en-US" sz="2025" dirty="0">
+                <a:solidFill>
+                  <a:srgbClr val="C8C8C8"/>
+                </a:solidFill>
+                <a:latin typeface="Arial" pitchFamily="34" charset="0"/>
+                <a:ea typeface="Arial" pitchFamily="34" charset="-122"/>
+                <a:cs typeface="Arial" pitchFamily="34" charset="-120"/>
+              </a:rPr>
+              <a:t> EIGER end to end — leak a secret, move money, approve a fraudulent dispute. Nothing abstract.</a:t>
             </a:r>
             <a:endParaRPr lang="en-US" sz="2025" dirty="0"/>
           </a:p>
@@ -5710,14 +5541,14 @@
       </p:sp>
       <p:pic>
         <p:nvPicPr>
-          <p:cNvPr id="12" name="Image 0" descr="preencoded.png">    </p:cNvPr>
+          <p:cNvPr id="12" name="Image 0" descr="preencoded.png"/>
           <p:cNvPicPr>
             <a:picLocks noChangeAspect="1"/>
           </p:cNvPicPr>
           <p:nvPr/>
         </p:nvPicPr>
         <p:blipFill>
-          <a:blip r:embed="rId1"/>
+          <a:blip r:embed="rId3"/>
           <a:stretch>
             <a:fillRect/>
           </a:stretch>
@@ -5755,11 +5586,11 @@
           </a:bodyPr>
           <a:lstStyle/>
           <a:p>
-            <a:pPr algn="l" indent="0" marL="0">
-              <a:buNone/>
-            </a:pPr>
-            <a:r>
-              <a:rPr lang="en-US" sz="1200" spc="264" kern="0" dirty="0">
+            <a:pPr marL="0" indent="0" algn="l">
+              <a:buNone/>
+            </a:pPr>
+            <a:r>
+              <a:rPr lang="en-US" sz="1200" kern="0" spc="264" dirty="0">
                 <a:solidFill>
                   <a:srgbClr val="969696"/>
                 </a:solidFill>
@@ -5789,6 +5620,7 @@
         <a:solidFill>
           <a:srgbClr val="000000"/>
         </a:solidFill>
+        <a:effectLst/>
       </p:bgPr>
     </p:bg>
     <p:spTree>
@@ -5828,11 +5660,11 @@
           </a:bodyPr>
           <a:lstStyle/>
           <a:p>
-            <a:pPr algn="l" indent="0" marL="0">
-              <a:buNone/>
-            </a:pPr>
-            <a:r>
-              <a:rPr lang="en-US" sz="1500" spc="450" kern="0" dirty="0">
+            <a:pPr marL="0" indent="0" algn="l">
+              <a:buNone/>
+            </a:pPr>
+            <a:r>
+              <a:rPr lang="en-US" sz="1500" kern="0" spc="450" dirty="0">
                 <a:solidFill>
                   <a:srgbClr val="36CDFF"/>
                 </a:solidFill>
@@ -5865,11 +5697,11 @@
         </p:spPr>
         <p:txBody>
           <a:bodyPr wrap="square" lIns="25400" tIns="25400" rIns="25400" bIns="25400" rtlCol="0" anchor="t">
-            <a:normAutofit/>
-          </a:bodyPr>
-          <a:lstStyle/>
-          <a:p>
-            <a:pPr algn="l" indent="0" marL="0">
+            <a:normAutofit lnSpcReduction="10000"/>
+          </a:bodyPr>
+          <a:lstStyle/>
+          <a:p>
+            <a:pPr marL="0" indent="0" algn="l">
               <a:lnSpc>
                 <a:spcPct val="78171"/>
               </a:lnSpc>
@@ -5884,7 +5716,7 @@
                 <a:ea typeface="Arial" pitchFamily="34" charset="-122"/>
                 <a:cs typeface="Arial" pitchFamily="34" charset="-120"/>
               </a:rPr>
-              <a:t>HALO GROWS TEETH EACH MODULE</a:t>
+              <a:t>IGGY GROWS TEETH EACH MODULE</a:t>
             </a:r>
             <a:endParaRPr lang="en-US" sz="5700" dirty="0"/>
           </a:p>
@@ -5911,6 +5743,13 @@
           </a:solidFill>
           <a:ln/>
         </p:spPr>
+        <p:txBody>
+          <a:bodyPr/>
+          <a:lstStyle/>
+          <a:p>
+            <a:endParaRPr lang="en-US"/>
+          </a:p>
+        </p:txBody>
       </p:sp>
       <p:sp>
         <p:nvSpPr>
@@ -5935,11 +5774,11 @@
           </a:bodyPr>
           <a:lstStyle/>
           <a:p>
-            <a:pPr algn="l" indent="0" marL="0">
-              <a:buNone/>
-            </a:pPr>
-            <a:r>
-              <a:rPr lang="en-US" sz="1350" spc="135" kern="0" dirty="0">
+            <a:pPr marL="0" indent="0" algn="l">
+              <a:buNone/>
+            </a:pPr>
+            <a:r>
+              <a:rPr lang="en-US" sz="1350" kern="0" spc="135" dirty="0">
                 <a:solidFill>
                   <a:srgbClr val="969696"/>
                 </a:solidFill>
@@ -5976,11 +5815,11 @@
           </a:bodyPr>
           <a:lstStyle/>
           <a:p>
-            <a:pPr algn="l" indent="0" marL="0">
-              <a:buNone/>
-            </a:pPr>
-            <a:r>
-              <a:rPr lang="en-US" sz="1350" spc="135" kern="0" dirty="0">
+            <a:pPr marL="0" indent="0" algn="l">
+              <a:buNone/>
+            </a:pPr>
+            <a:r>
+              <a:rPr lang="en-US" sz="1350" kern="0" spc="135" dirty="0">
                 <a:solidFill>
                   <a:srgbClr val="36CDFF"/>
                 </a:solidFill>
@@ -6017,11 +5856,11 @@
           </a:bodyPr>
           <a:lstStyle/>
           <a:p>
-            <a:pPr algn="l" indent="0" marL="0">
-              <a:buNone/>
-            </a:pPr>
-            <a:r>
-              <a:rPr lang="en-US" sz="1350" spc="135" kern="0" dirty="0">
+            <a:pPr marL="0" indent="0" algn="l">
+              <a:buNone/>
+            </a:pPr>
+            <a:r>
+              <a:rPr lang="en-US" sz="1350" kern="0" spc="135" dirty="0">
                 <a:solidFill>
                   <a:srgbClr val="FD7EF5"/>
                 </a:solidFill>
@@ -6056,6 +5895,13 @@
           </a:solidFill>
           <a:ln/>
         </p:spPr>
+        <p:txBody>
+          <a:bodyPr/>
+          <a:lstStyle/>
+          <a:p>
+            <a:endParaRPr lang="en-US"/>
+          </a:p>
+        </p:txBody>
       </p:sp>
       <p:sp>
         <p:nvSpPr>
@@ -6080,7 +5926,7 @@
           </a:bodyPr>
           <a:lstStyle/>
           <a:p>
-            <a:pPr algn="l" indent="0" marL="0">
+            <a:pPr marL="0" indent="0" algn="l">
               <a:lnSpc>
                 <a:spcPct val="116379"/>
               </a:lnSpc>
@@ -6122,6 +5968,13 @@
           </a:solidFill>
           <a:ln/>
         </p:spPr>
+        <p:txBody>
+          <a:bodyPr/>
+          <a:lstStyle/>
+          <a:p>
+            <a:endParaRPr lang="en-US"/>
+          </a:p>
+        </p:txBody>
       </p:sp>
       <p:sp>
         <p:nvSpPr>
@@ -6146,7 +5999,7 @@
           </a:bodyPr>
           <a:lstStyle/>
           <a:p>
-            <a:pPr algn="l" indent="0" marL="0">
+            <a:pPr marL="0" indent="0" algn="l">
               <a:lnSpc>
                 <a:spcPct val="116379"/>
               </a:lnSpc>
@@ -6188,6 +6041,13 @@
           </a:solidFill>
           <a:ln/>
         </p:spPr>
+        <p:txBody>
+          <a:bodyPr/>
+          <a:lstStyle/>
+          <a:p>
+            <a:endParaRPr lang="en-US"/>
+          </a:p>
+        </p:txBody>
       </p:sp>
       <p:sp>
         <p:nvSpPr>
@@ -6212,7 +6072,7 @@
           </a:bodyPr>
           <a:lstStyle/>
           <a:p>
-            <a:pPr algn="l" indent="0" marL="0">
+            <a:pPr marL="0" indent="0" algn="l">
               <a:lnSpc>
                 <a:spcPct val="116379"/>
               </a:lnSpc>
@@ -6254,6 +6114,13 @@
           </a:solidFill>
           <a:ln/>
         </p:spPr>
+        <p:txBody>
+          <a:bodyPr/>
+          <a:lstStyle/>
+          <a:p>
+            <a:endParaRPr lang="en-US"/>
+          </a:p>
+        </p:txBody>
       </p:sp>
       <p:sp>
         <p:nvSpPr>
@@ -6276,6 +6143,13 @@
           </a:solidFill>
           <a:ln/>
         </p:spPr>
+        <p:txBody>
+          <a:bodyPr/>
+          <a:lstStyle/>
+          <a:p>
+            <a:endParaRPr lang="en-US"/>
+          </a:p>
+        </p:txBody>
       </p:sp>
       <p:sp>
         <p:nvSpPr>
@@ -6300,7 +6174,7 @@
           </a:bodyPr>
           <a:lstStyle/>
           <a:p>
-            <a:pPr algn="l" indent="0" marL="0">
+            <a:pPr marL="0" indent="0" algn="l">
               <a:lnSpc>
                 <a:spcPct val="116379"/>
               </a:lnSpc>
@@ -6342,6 +6216,13 @@
           </a:solidFill>
           <a:ln/>
         </p:spPr>
+        <p:txBody>
+          <a:bodyPr/>
+          <a:lstStyle/>
+          <a:p>
+            <a:endParaRPr lang="en-US"/>
+          </a:p>
+        </p:txBody>
       </p:sp>
       <p:sp>
         <p:nvSpPr>
@@ -6364,6 +6245,13 @@
           </a:solidFill>
           <a:ln/>
         </p:spPr>
+        <p:txBody>
+          <a:bodyPr/>
+          <a:lstStyle/>
+          <a:p>
+            <a:endParaRPr lang="en-US"/>
+          </a:p>
+        </p:txBody>
       </p:sp>
       <p:sp>
         <p:nvSpPr>
@@ -6388,7 +6276,7 @@
           </a:bodyPr>
           <a:lstStyle/>
           <a:p>
-            <a:pPr algn="l" indent="0" marL="0">
+            <a:pPr marL="0" indent="0" algn="l">
               <a:lnSpc>
                 <a:spcPct val="116379"/>
               </a:lnSpc>
@@ -6430,6 +6318,13 @@
           </a:solidFill>
           <a:ln/>
         </p:spPr>
+        <p:txBody>
+          <a:bodyPr/>
+          <a:lstStyle/>
+          <a:p>
+            <a:endParaRPr lang="en-US"/>
+          </a:p>
+        </p:txBody>
       </p:sp>
       <p:sp>
         <p:nvSpPr>
@@ -6452,6 +6347,13 @@
           </a:solidFill>
           <a:ln/>
         </p:spPr>
+        <p:txBody>
+          <a:bodyPr/>
+          <a:lstStyle/>
+          <a:p>
+            <a:endParaRPr lang="en-US"/>
+          </a:p>
+        </p:txBody>
       </p:sp>
       <p:sp>
         <p:nvSpPr>
@@ -6476,7 +6378,7 @@
           </a:bodyPr>
           <a:lstStyle/>
           <a:p>
-            <a:pPr algn="l" indent="0" marL="0">
+            <a:pPr marL="0" indent="0" algn="l">
               <a:lnSpc>
                 <a:spcPct val="116379"/>
               </a:lnSpc>
@@ -6518,6 +6420,13 @@
           </a:solidFill>
           <a:ln/>
         </p:spPr>
+        <p:txBody>
+          <a:bodyPr/>
+          <a:lstStyle/>
+          <a:p>
+            <a:endParaRPr lang="en-US"/>
+          </a:p>
+        </p:txBody>
       </p:sp>
       <p:sp>
         <p:nvSpPr>
@@ -6542,7 +6451,7 @@
           </a:bodyPr>
           <a:lstStyle/>
           <a:p>
-            <a:pPr algn="l" indent="0" marL="0">
+            <a:pPr marL="0" indent="0" algn="l">
               <a:lnSpc>
                 <a:spcPct val="116379"/>
               </a:lnSpc>
@@ -6584,6 +6493,13 @@
           </a:solidFill>
           <a:ln/>
         </p:spPr>
+        <p:txBody>
+          <a:bodyPr/>
+          <a:lstStyle/>
+          <a:p>
+            <a:endParaRPr lang="en-US"/>
+          </a:p>
+        </p:txBody>
       </p:sp>
       <p:sp>
         <p:nvSpPr>
@@ -6608,7 +6524,7 @@
           </a:bodyPr>
           <a:lstStyle/>
           <a:p>
-            <a:pPr algn="l" indent="0" marL="0">
+            <a:pPr marL="0" indent="0" algn="l">
               <a:lnSpc>
                 <a:spcPct val="116379"/>
               </a:lnSpc>
@@ -6650,6 +6566,13 @@
           </a:solidFill>
           <a:ln/>
         </p:spPr>
+        <p:txBody>
+          <a:bodyPr/>
+          <a:lstStyle/>
+          <a:p>
+            <a:endParaRPr lang="en-US"/>
+          </a:p>
+        </p:txBody>
       </p:sp>
       <p:sp>
         <p:nvSpPr>
@@ -6674,7 +6597,7 @@
           </a:bodyPr>
           <a:lstStyle/>
           <a:p>
-            <a:pPr algn="l" indent="0" marL="0">
+            <a:pPr marL="0" indent="0" algn="l">
               <a:lnSpc>
                 <a:spcPct val="116379"/>
               </a:lnSpc>
@@ -6716,6 +6639,13 @@
           </a:solidFill>
           <a:ln/>
         </p:spPr>
+        <p:txBody>
+          <a:bodyPr/>
+          <a:lstStyle/>
+          <a:p>
+            <a:endParaRPr lang="en-US"/>
+          </a:p>
+        </p:txBody>
       </p:sp>
       <p:sp>
         <p:nvSpPr>
@@ -6738,6 +6668,13 @@
           </a:solidFill>
           <a:ln/>
         </p:spPr>
+        <p:txBody>
+          <a:bodyPr/>
+          <a:lstStyle/>
+          <a:p>
+            <a:endParaRPr lang="en-US"/>
+          </a:p>
+        </p:txBody>
       </p:sp>
       <p:sp>
         <p:nvSpPr>
@@ -6762,7 +6699,7 @@
           </a:bodyPr>
           <a:lstStyle/>
           <a:p>
-            <a:pPr algn="l" indent="0" marL="0">
+            <a:pPr marL="0" indent="0" algn="l">
               <a:lnSpc>
                 <a:spcPct val="116379"/>
               </a:lnSpc>
@@ -6804,6 +6741,13 @@
           </a:solidFill>
           <a:ln/>
         </p:spPr>
+        <p:txBody>
+          <a:bodyPr/>
+          <a:lstStyle/>
+          <a:p>
+            <a:endParaRPr lang="en-US"/>
+          </a:p>
+        </p:txBody>
       </p:sp>
       <p:sp>
         <p:nvSpPr>
@@ -6826,6 +6770,13 @@
           </a:solidFill>
           <a:ln/>
         </p:spPr>
+        <p:txBody>
+          <a:bodyPr/>
+          <a:lstStyle/>
+          <a:p>
+            <a:endParaRPr lang="en-US"/>
+          </a:p>
+        </p:txBody>
       </p:sp>
       <p:sp>
         <p:nvSpPr>
@@ -6850,7 +6801,7 @@
           </a:bodyPr>
           <a:lstStyle/>
           <a:p>
-            <a:pPr algn="l" indent="0" marL="0">
+            <a:pPr marL="0" indent="0" algn="l">
               <a:lnSpc>
                 <a:spcPct val="116379"/>
               </a:lnSpc>
@@ -6892,6 +6843,13 @@
           </a:solidFill>
           <a:ln/>
         </p:spPr>
+        <p:txBody>
+          <a:bodyPr/>
+          <a:lstStyle/>
+          <a:p>
+            <a:endParaRPr lang="en-US"/>
+          </a:p>
+        </p:txBody>
       </p:sp>
       <p:sp>
         <p:nvSpPr>
@@ -6914,6 +6872,13 @@
           </a:solidFill>
           <a:ln/>
         </p:spPr>
+        <p:txBody>
+          <a:bodyPr/>
+          <a:lstStyle/>
+          <a:p>
+            <a:endParaRPr lang="en-US"/>
+          </a:p>
+        </p:txBody>
       </p:sp>
       <p:sp>
         <p:nvSpPr>
@@ -6938,7 +6903,7 @@
           </a:bodyPr>
           <a:lstStyle/>
           <a:p>
-            <a:pPr algn="l" indent="0" marL="0">
+            <a:pPr marL="0" indent="0" algn="l">
               <a:lnSpc>
                 <a:spcPct val="116379"/>
               </a:lnSpc>
@@ -6980,6 +6945,13 @@
           </a:solidFill>
           <a:ln/>
         </p:spPr>
+        <p:txBody>
+          <a:bodyPr/>
+          <a:lstStyle/>
+          <a:p>
+            <a:endParaRPr lang="en-US"/>
+          </a:p>
+        </p:txBody>
       </p:sp>
       <p:sp>
         <p:nvSpPr>
@@ -7004,7 +6976,7 @@
           </a:bodyPr>
           <a:lstStyle/>
           <a:p>
-            <a:pPr algn="l" indent="0" marL="0">
+            <a:pPr marL="0" indent="0" algn="l">
               <a:lnSpc>
                 <a:spcPct val="116379"/>
               </a:lnSpc>
@@ -7046,6 +7018,13 @@
           </a:solidFill>
           <a:ln/>
         </p:spPr>
+        <p:txBody>
+          <a:bodyPr/>
+          <a:lstStyle/>
+          <a:p>
+            <a:endParaRPr lang="en-US"/>
+          </a:p>
+        </p:txBody>
       </p:sp>
       <p:sp>
         <p:nvSpPr>
@@ -7070,7 +7049,7 @@
           </a:bodyPr>
           <a:lstStyle/>
           <a:p>
-            <a:pPr algn="l" indent="0" marL="0">
+            <a:pPr marL="0" indent="0" algn="l">
               <a:lnSpc>
                 <a:spcPct val="116379"/>
               </a:lnSpc>
@@ -7112,6 +7091,13 @@
           </a:solidFill>
           <a:ln/>
         </p:spPr>
+        <p:txBody>
+          <a:bodyPr/>
+          <a:lstStyle/>
+          <a:p>
+            <a:endParaRPr lang="en-US"/>
+          </a:p>
+        </p:txBody>
       </p:sp>
       <p:sp>
         <p:nvSpPr>
@@ -7136,7 +7122,7 @@
           </a:bodyPr>
           <a:lstStyle/>
           <a:p>
-            <a:pPr algn="l" indent="0" marL="0">
+            <a:pPr marL="0" indent="0" algn="l">
               <a:lnSpc>
                 <a:spcPct val="116379"/>
               </a:lnSpc>
@@ -7178,6 +7164,13 @@
           </a:solidFill>
           <a:ln/>
         </p:spPr>
+        <p:txBody>
+          <a:bodyPr/>
+          <a:lstStyle/>
+          <a:p>
+            <a:endParaRPr lang="en-US"/>
+          </a:p>
+        </p:txBody>
       </p:sp>
       <p:sp>
         <p:nvSpPr>
@@ -7200,6 +7193,13 @@
           </a:solidFill>
           <a:ln/>
         </p:spPr>
+        <p:txBody>
+          <a:bodyPr/>
+          <a:lstStyle/>
+          <a:p>
+            <a:endParaRPr lang="en-US"/>
+          </a:p>
+        </p:txBody>
       </p:sp>
       <p:sp>
         <p:nvSpPr>
@@ -7224,7 +7224,7 @@
           </a:bodyPr>
           <a:lstStyle/>
           <a:p>
-            <a:pPr algn="l" indent="0" marL="0">
+            <a:pPr marL="0" indent="0" algn="l">
               <a:lnSpc>
                 <a:spcPct val="116379"/>
               </a:lnSpc>
@@ -7266,6 +7266,13 @@
           </a:solidFill>
           <a:ln/>
         </p:spPr>
+        <p:txBody>
+          <a:bodyPr/>
+          <a:lstStyle/>
+          <a:p>
+            <a:endParaRPr lang="en-US"/>
+          </a:p>
+        </p:txBody>
       </p:sp>
       <p:sp>
         <p:nvSpPr>
@@ -7288,6 +7295,13 @@
           </a:solidFill>
           <a:ln/>
         </p:spPr>
+        <p:txBody>
+          <a:bodyPr/>
+          <a:lstStyle/>
+          <a:p>
+            <a:endParaRPr lang="en-US"/>
+          </a:p>
+        </p:txBody>
       </p:sp>
       <p:sp>
         <p:nvSpPr>
@@ -7312,7 +7326,7 @@
           </a:bodyPr>
           <a:lstStyle/>
           <a:p>
-            <a:pPr algn="l" indent="0" marL="0">
+            <a:pPr marL="0" indent="0" algn="l">
               <a:lnSpc>
                 <a:spcPct val="116379"/>
               </a:lnSpc>
@@ -7354,6 +7368,13 @@
           </a:solidFill>
           <a:ln/>
         </p:spPr>
+        <p:txBody>
+          <a:bodyPr/>
+          <a:lstStyle/>
+          <a:p>
+            <a:endParaRPr lang="en-US"/>
+          </a:p>
+        </p:txBody>
       </p:sp>
       <p:sp>
         <p:nvSpPr>
@@ -7376,6 +7397,13 @@
           </a:solidFill>
           <a:ln/>
         </p:spPr>
+        <p:txBody>
+          <a:bodyPr/>
+          <a:lstStyle/>
+          <a:p>
+            <a:endParaRPr lang="en-US"/>
+          </a:p>
+        </p:txBody>
       </p:sp>
       <p:sp>
         <p:nvSpPr>
@@ -7400,7 +7428,7 @@
           </a:bodyPr>
           <a:lstStyle/>
           <a:p>
-            <a:pPr algn="l" indent="0" marL="0">
+            <a:pPr marL="0" indent="0" algn="l">
               <a:lnSpc>
                 <a:spcPct val="116379"/>
               </a:lnSpc>
@@ -7444,7 +7472,7 @@
           </a:bodyPr>
           <a:lstStyle/>
           <a:p>
-            <a:pPr algn="l" indent="0" marL="0">
+            <a:pPr marL="0" indent="0" algn="l">
               <a:buNone/>
             </a:pPr>
             <a:r>
@@ -7464,14 +7492,14 @@
       </p:sp>
       <p:pic>
         <p:nvPicPr>
-          <p:cNvPr id="54" name="Image 0" descr="preencoded.png">    </p:cNvPr>
+          <p:cNvPr id="54" name="Image 0" descr="preencoded.png"/>
           <p:cNvPicPr>
             <a:picLocks noChangeAspect="1"/>
           </p:cNvPicPr>
           <p:nvPr/>
         </p:nvPicPr>
         <p:blipFill>
-          <a:blip r:embed="rId1"/>
+          <a:blip r:embed="rId3"/>
           <a:stretch>
             <a:fillRect/>
           </a:stretch>
@@ -7509,11 +7537,11 @@
           </a:bodyPr>
           <a:lstStyle/>
           <a:p>
-            <a:pPr algn="l" indent="0" marL="0">
-              <a:buNone/>
-            </a:pPr>
-            <a:r>
-              <a:rPr lang="en-US" sz="1200" spc="264" kern="0" dirty="0">
+            <a:pPr marL="0" indent="0" algn="l">
+              <a:buNone/>
+            </a:pPr>
+            <a:r>
+              <a:rPr lang="en-US" sz="1200" kern="0" spc="264" dirty="0">
                 <a:solidFill>
                   <a:srgbClr val="969696"/>
                 </a:solidFill>
@@ -7543,6 +7571,7 @@
         <a:solidFill>
           <a:srgbClr val="000000"/>
         </a:solidFill>
+        <a:effectLst/>
       </p:bgPr>
     </p:bg>
     <p:spTree>
@@ -7582,11 +7611,11 @@
           </a:bodyPr>
           <a:lstStyle/>
           <a:p>
-            <a:pPr algn="l" indent="0" marL="0">
-              <a:buNone/>
-            </a:pPr>
-            <a:r>
-              <a:rPr lang="en-US" sz="1500" spc="450" kern="0" dirty="0">
+            <a:pPr marL="0" indent="0" algn="l">
+              <a:buNone/>
+            </a:pPr>
+            <a:r>
+              <a:rPr lang="en-US" sz="1500" kern="0" spc="450" dirty="0">
                 <a:solidFill>
                   <a:srgbClr val="36CDFF"/>
                 </a:solidFill>
@@ -7623,7 +7652,7 @@
           </a:bodyPr>
           <a:lstStyle/>
           <a:p>
-            <a:pPr algn="l" indent="0" marL="0">
+            <a:pPr marL="0" indent="0" algn="l">
               <a:lnSpc>
                 <a:spcPct val="78190"/>
               </a:lnSpc>
@@ -7667,7 +7696,7 @@
           </a:bodyPr>
           <a:lstStyle/>
           <a:p>
-            <a:pPr algn="l" indent="0" marL="0">
+            <a:pPr marL="0" indent="0" algn="l">
               <a:lnSpc>
                 <a:spcPct val="123795"/>
               </a:lnSpc>
@@ -7684,12 +7713,6 @@
               </a:rPr>
               <a:t>Pass/fail is a </a:t>
             </a:r>
-            <a:pPr algn="l" indent="0" marL="0">
-              <a:lnSpc>
-                <a:spcPct val="123795"/>
-              </a:lnSpc>
-              <a:buNone/>
-            </a:pPr>
             <a:r>
               <a:rPr lang="en-US" sz="2550" b="1" dirty="0">
                 <a:solidFill>
@@ -7701,12 +7724,6 @@
               </a:rPr>
               <a:t>server-side audit log </a:t>
             </a:r>
-            <a:pPr algn="l" indent="0" marL="0">
-              <a:lnSpc>
-                <a:spcPct val="123795"/>
-              </a:lnSpc>
-              <a:buNone/>
-            </a:pPr>
             <a:r>
               <a:rPr lang="en-US" sz="2550" dirty="0">
                 <a:solidFill>
@@ -7718,12 +7735,6 @@
               </a:rPr>
               <a:t>— not what the model </a:t>
             </a:r>
-            <a:pPr algn="l" indent="0" marL="0">
-              <a:lnSpc>
-                <a:spcPct val="123795"/>
-              </a:lnSpc>
-              <a:buNone/>
-            </a:pPr>
             <a:r>
               <a:rPr lang="en-US" sz="2550" i="1" dirty="0">
                 <a:solidFill>
@@ -7760,6 +7771,13 @@
           </a:solidFill>
           <a:ln/>
         </p:spPr>
+        <p:txBody>
+          <a:bodyPr/>
+          <a:lstStyle/>
+          <a:p>
+            <a:endParaRPr lang="en-US"/>
+          </a:p>
+        </p:txBody>
       </p:sp>
       <p:sp>
         <p:nvSpPr>
@@ -7782,6 +7800,13 @@
           </a:solidFill>
           <a:ln/>
         </p:spPr>
+        <p:txBody>
+          <a:bodyPr/>
+          <a:lstStyle/>
+          <a:p>
+            <a:endParaRPr lang="en-US"/>
+          </a:p>
+        </p:txBody>
       </p:sp>
       <p:sp>
         <p:nvSpPr>
@@ -7802,6 +7827,13 @@
           </a:solidFill>
           <a:ln/>
         </p:spPr>
+        <p:txBody>
+          <a:bodyPr/>
+          <a:lstStyle/>
+          <a:p>
+            <a:endParaRPr lang="en-US"/>
+          </a:p>
+        </p:txBody>
       </p:sp>
       <p:sp>
         <p:nvSpPr>
@@ -7824,6 +7856,13 @@
           </a:solidFill>
           <a:ln/>
         </p:spPr>
+        <p:txBody>
+          <a:bodyPr/>
+          <a:lstStyle/>
+          <a:p>
+            <a:endParaRPr lang="en-US"/>
+          </a:p>
+        </p:txBody>
       </p:sp>
       <p:sp>
         <p:nvSpPr>
@@ -7848,7 +7887,7 @@
           </a:bodyPr>
           <a:lstStyle/>
           <a:p>
-            <a:pPr algn="l" indent="0" marL="0">
+            <a:pPr marL="0" indent="0" algn="l">
               <a:lnSpc>
                 <a:spcPct val="130645"/>
               </a:lnSpc>
@@ -7865,12 +7904,6 @@
               </a:rPr>
               <a:t>LLMs are non-deterministic, so we never grade on words. Every objective is validated by a mechanism query: did the exploit actually fire? You will see </a:t>
             </a:r>
-            <a:pPr algn="l" indent="0" marL="0">
-              <a:lnSpc>
-                <a:spcPct val="130645"/>
-              </a:lnSpc>
-              <a:buNone/>
-            </a:pPr>
             <a:r>
               <a:rPr lang="en-US" sz="2025" dirty="0">
                 <a:solidFill>
@@ -7882,12 +7915,6 @@
               </a:rPr>
               <a:t>/validate </a:t>
             </a:r>
-            <a:pPr algn="l" indent="0" marL="0">
-              <a:lnSpc>
-                <a:spcPct val="130645"/>
-              </a:lnSpc>
-              <a:buNone/>
-            </a:pPr>
             <a:r>
               <a:rPr lang="en-US" sz="2025" dirty="0">
                 <a:solidFill>
@@ -7899,12 +7926,6 @@
               </a:rPr>
               <a:t>return </a:t>
             </a:r>
-            <a:pPr algn="l" indent="0" marL="0">
-              <a:lnSpc>
-                <a:spcPct val="130645"/>
-              </a:lnSpc>
-              <a:buNone/>
-            </a:pPr>
             <a:r>
               <a:rPr lang="en-US" sz="2025" dirty="0">
                 <a:solidFill>
@@ -7916,12 +7937,6 @@
               </a:rPr>
               <a:t>core: pass</a:t>
             </a:r>
-            <a:pPr algn="l" indent="0" marL="0">
-              <a:lnSpc>
-                <a:spcPct val="130645"/>
-              </a:lnSpc>
-              <a:buNone/>
-            </a:pPr>
             <a:r>
               <a:rPr lang="en-US" sz="2025" dirty="0">
                 <a:solidFill>
@@ -7939,14 +7954,14 @@
       </p:sp>
       <p:pic>
         <p:nvPicPr>
-          <p:cNvPr id="10" name="Image 0" descr="preencoded.png">    </p:cNvPr>
+          <p:cNvPr id="10" name="Image 0" descr="preencoded.png"/>
           <p:cNvPicPr>
             <a:picLocks noChangeAspect="1"/>
           </p:cNvPicPr>
           <p:nvPr/>
         </p:nvPicPr>
         <p:blipFill>
-          <a:blip r:embed="rId1"/>
+          <a:blip r:embed="rId3"/>
           <a:stretch>
             <a:fillRect/>
           </a:stretch>
@@ -7984,11 +7999,11 @@
           </a:bodyPr>
           <a:lstStyle/>
           <a:p>
-            <a:pPr algn="l" indent="0" marL="0">
-              <a:buNone/>
-            </a:pPr>
-            <a:r>
-              <a:rPr lang="en-US" sz="1200" spc="264" kern="0" dirty="0">
+            <a:pPr marL="0" indent="0" algn="l">
+              <a:buNone/>
+            </a:pPr>
+            <a:r>
+              <a:rPr lang="en-US" sz="1200" kern="0" spc="264" dirty="0">
                 <a:solidFill>
                   <a:srgbClr val="969696"/>
                 </a:solidFill>
@@ -8018,6 +8033,7 @@
         <a:solidFill>
           <a:srgbClr val="000000"/>
         </a:solidFill>
+        <a:effectLst/>
       </p:bgPr>
     </p:bg>
     <p:spTree>
@@ -8057,11 +8073,11 @@
           </a:bodyPr>
           <a:lstStyle/>
           <a:p>
-            <a:pPr algn="l" indent="0" marL="0">
-              <a:buNone/>
-            </a:pPr>
-            <a:r>
-              <a:rPr lang="en-US" sz="1500" spc="450" kern="0" dirty="0">
+            <a:pPr marL="0" indent="0" algn="l">
+              <a:buNone/>
+            </a:pPr>
+            <a:r>
+              <a:rPr lang="en-US" sz="1500" kern="0" spc="450" dirty="0">
                 <a:solidFill>
                   <a:srgbClr val="36CDFF"/>
                 </a:solidFill>
@@ -8098,7 +8114,7 @@
           </a:bodyPr>
           <a:lstStyle/>
           <a:p>
-            <a:pPr algn="l" indent="0" marL="0">
+            <a:pPr marL="0" indent="0" algn="l">
               <a:lnSpc>
                 <a:spcPct val="78190"/>
               </a:lnSpc>
@@ -8140,6 +8156,13 @@
           </a:solidFill>
           <a:ln/>
         </p:spPr>
+        <p:txBody>
+          <a:bodyPr/>
+          <a:lstStyle/>
+          <a:p>
+            <a:endParaRPr lang="en-US"/>
+          </a:p>
+        </p:txBody>
       </p:sp>
       <p:sp>
         <p:nvSpPr>
@@ -8164,7 +8187,7 @@
           </a:bodyPr>
           <a:lstStyle/>
           <a:p>
-            <a:pPr algn="l" indent="0" marL="0">
+            <a:pPr marL="0" indent="0" algn="l">
               <a:buNone/>
             </a:pPr>
             <a:r>
@@ -8205,7 +8228,7 @@
           </a:bodyPr>
           <a:lstStyle/>
           <a:p>
-            <a:pPr algn="l" indent="0" marL="0">
+            <a:pPr marL="0" indent="0" algn="l">
               <a:lnSpc>
                 <a:spcPct val="108108"/>
               </a:lnSpc>
@@ -8249,7 +8272,7 @@
           </a:bodyPr>
           <a:lstStyle/>
           <a:p>
-            <a:pPr algn="l" indent="0" marL="0">
+            <a:pPr marL="0" indent="0" algn="l">
               <a:lnSpc>
                 <a:spcPct val="125000"/>
               </a:lnSpc>
@@ -8266,12 +8289,6 @@
               </a:rPr>
               <a:t>vulnerable </a:t>
             </a:r>
-            <a:pPr algn="l" indent="0" marL="0">
-              <a:lnSpc>
-                <a:spcPct val="125000"/>
-              </a:lnSpc>
-              <a:buNone/>
-            </a:pPr>
             <a:r>
               <a:rPr lang="en-US" sz="1875" dirty="0">
                 <a:solidFill>
@@ -8283,12 +8300,6 @@
               </a:rPr>
               <a:t>↔ </a:t>
             </a:r>
-            <a:pPr algn="l" indent="0" marL="0">
-              <a:lnSpc>
-                <a:spcPct val="125000"/>
-              </a:lnSpc>
-              <a:buNone/>
-            </a:pPr>
             <a:r>
               <a:rPr lang="en-US" sz="1875" dirty="0">
                 <a:solidFill>
@@ -8300,12 +8311,6 @@
               </a:rPr>
               <a:t>secure</a:t>
             </a:r>
-            <a:pPr algn="l" indent="0" marL="0">
-              <a:lnSpc>
-                <a:spcPct val="125000"/>
-              </a:lnSpc>
-              <a:buNone/>
-            </a:pPr>
             <a:r>
               <a:rPr lang="en-US" sz="1875" dirty="0">
                 <a:solidFill>
@@ -8342,6 +8347,13 @@
           </a:solidFill>
           <a:ln/>
         </p:spPr>
+        <p:txBody>
+          <a:bodyPr/>
+          <a:lstStyle/>
+          <a:p>
+            <a:endParaRPr lang="en-US"/>
+          </a:p>
+        </p:txBody>
       </p:sp>
       <p:sp>
         <p:nvSpPr>
@@ -8366,7 +8378,7 @@
           </a:bodyPr>
           <a:lstStyle/>
           <a:p>
-            <a:pPr algn="l" indent="0" marL="0">
+            <a:pPr marL="0" indent="0" algn="l">
               <a:buNone/>
             </a:pPr>
             <a:r>
@@ -8407,7 +8419,7 @@
           </a:bodyPr>
           <a:lstStyle/>
           <a:p>
-            <a:pPr algn="l" indent="0" marL="0">
+            <a:pPr marL="0" indent="0" algn="l">
               <a:lnSpc>
                 <a:spcPct val="108108"/>
               </a:lnSpc>
@@ -8451,7 +8463,7 @@
           </a:bodyPr>
           <a:lstStyle/>
           <a:p>
-            <a:pPr algn="l" indent="0" marL="0">
+            <a:pPr marL="0" indent="0" algn="l">
               <a:lnSpc>
                 <a:spcPct val="125000"/>
               </a:lnSpc>
@@ -8493,6 +8505,13 @@
           </a:solidFill>
           <a:ln/>
         </p:spPr>
+        <p:txBody>
+          <a:bodyPr/>
+          <a:lstStyle/>
+          <a:p>
+            <a:endParaRPr lang="en-US"/>
+          </a:p>
+        </p:txBody>
       </p:sp>
       <p:sp>
         <p:nvSpPr>
@@ -8517,7 +8536,7 @@
           </a:bodyPr>
           <a:lstStyle/>
           <a:p>
-            <a:pPr algn="l" indent="0" marL="0">
+            <a:pPr marL="0" indent="0" algn="l">
               <a:buNone/>
             </a:pPr>
             <a:r>
@@ -8558,7 +8577,7 @@
           </a:bodyPr>
           <a:lstStyle/>
           <a:p>
-            <a:pPr algn="l" indent="0" marL="0">
+            <a:pPr marL="0" indent="0" algn="l">
               <a:lnSpc>
                 <a:spcPct val="108108"/>
               </a:lnSpc>
@@ -8602,7 +8621,7 @@
           </a:bodyPr>
           <a:lstStyle/>
           <a:p>
-            <a:pPr algn="l" indent="0" marL="0">
+            <a:pPr marL="0" indent="0" algn="l">
               <a:lnSpc>
                 <a:spcPct val="125000"/>
               </a:lnSpc>
@@ -8644,6 +8663,13 @@
           </a:solidFill>
           <a:ln/>
         </p:spPr>
+        <p:txBody>
+          <a:bodyPr/>
+          <a:lstStyle/>
+          <a:p>
+            <a:endParaRPr lang="en-US"/>
+          </a:p>
+        </p:txBody>
       </p:sp>
       <p:sp>
         <p:nvSpPr>
@@ -8668,7 +8694,7 @@
           </a:bodyPr>
           <a:lstStyle/>
           <a:p>
-            <a:pPr algn="l" indent="0" marL="0">
+            <a:pPr marL="0" indent="0" algn="l">
               <a:buNone/>
             </a:pPr>
             <a:r>
@@ -8709,7 +8735,7 @@
           </a:bodyPr>
           <a:lstStyle/>
           <a:p>
-            <a:pPr algn="l" indent="0" marL="0">
+            <a:pPr marL="0" indent="0" algn="l">
               <a:lnSpc>
                 <a:spcPct val="108108"/>
               </a:lnSpc>
@@ -8753,7 +8779,7 @@
           </a:bodyPr>
           <a:lstStyle/>
           <a:p>
-            <a:pPr algn="l" indent="0" marL="0">
+            <a:pPr marL="0" indent="0" algn="l">
               <a:lnSpc>
                 <a:spcPct val="125000"/>
               </a:lnSpc>
@@ -8776,14 +8802,14 @@
       </p:sp>
       <p:pic>
         <p:nvPicPr>
-          <p:cNvPr id="20" name="Image 0" descr="preencoded.png">    </p:cNvPr>
+          <p:cNvPr id="20" name="Image 0" descr="preencoded.png"/>
           <p:cNvPicPr>
             <a:picLocks noChangeAspect="1"/>
           </p:cNvPicPr>
           <p:nvPr/>
         </p:nvPicPr>
         <p:blipFill>
-          <a:blip r:embed="rId1"/>
+          <a:blip r:embed="rId3"/>
           <a:stretch>
             <a:fillRect/>
           </a:stretch>
@@ -8821,11 +8847,11 @@
           </a:bodyPr>
           <a:lstStyle/>
           <a:p>
-            <a:pPr algn="l" indent="0" marL="0">
-              <a:buNone/>
-            </a:pPr>
-            <a:r>
-              <a:rPr lang="en-US" sz="1200" spc="264" kern="0" dirty="0">
+            <a:pPr marL="0" indent="0" algn="l">
+              <a:buNone/>
+            </a:pPr>
+            <a:r>
+              <a:rPr lang="en-US" sz="1200" kern="0" spc="264" dirty="0">
                 <a:solidFill>
                   <a:srgbClr val="969696"/>
                 </a:solidFill>
@@ -9140,4 +9166,319 @@
     </a:ext>
   </a:extLst>
 </a:theme>
+</file>
+
+<file path=ppt/theme/theme2.xml><?xml version="1.0" encoding="utf-8"?>
+<a:theme xmlns:a="http://schemas.openxmlformats.org/drawingml/2006/main" name="Office Theme">
+  <a:themeElements>
+    <a:clrScheme name="Office">
+      <a:dk1>
+        <a:sysClr val="windowText" lastClr="000000"/>
+      </a:dk1>
+      <a:lt1>
+        <a:sysClr val="window" lastClr="FFFFFF"/>
+      </a:lt1>
+      <a:dk2>
+        <a:srgbClr val="0E2841"/>
+      </a:dk2>
+      <a:lt2>
+        <a:srgbClr val="E8E8E8"/>
+      </a:lt2>
+      <a:accent1>
+        <a:srgbClr val="156082"/>
+      </a:accent1>
+      <a:accent2>
+        <a:srgbClr val="E97132"/>
+      </a:accent2>
+      <a:accent3>
+        <a:srgbClr val="196B24"/>
+      </a:accent3>
+      <a:accent4>
+        <a:srgbClr val="0F9ED5"/>
+      </a:accent4>
+      <a:accent5>
+        <a:srgbClr val="A02B93"/>
+      </a:accent5>
+      <a:accent6>
+        <a:srgbClr val="4EA72E"/>
+      </a:accent6>
+      <a:hlink>
+        <a:srgbClr val="467886"/>
+      </a:hlink>
+      <a:folHlink>
+        <a:srgbClr val="96607D"/>
+      </a:folHlink>
+    </a:clrScheme>
+    <a:fontScheme name="Office">
+      <a:majorFont>
+        <a:latin typeface="Aptos Display" panose="02110004020202020204"/>
+        <a:ea typeface=""/>
+        <a:cs typeface=""/>
+        <a:font script="Jpan" typeface="游ゴシック Light"/>
+        <a:font script="Hang" typeface="맑은 고딕"/>
+        <a:font script="Hans" typeface="等线 Light"/>
+        <a:font script="Hant" typeface="新細明體"/>
+        <a:font script="Arab" typeface="Times New Roman"/>
+        <a:font script="Hebr" typeface="Times New Roman"/>
+        <a:font script="Thai" typeface="Angsana New"/>
+        <a:font script="Ethi" typeface="Nyala"/>
+        <a:font script="Beng" typeface="Vrinda"/>
+        <a:font script="Gujr" typeface="Shruti"/>
+        <a:font script="Khmr" typeface="MoolBoran"/>
+        <a:font script="Knda" typeface="Tunga"/>
+        <a:font script="Guru" typeface="Raavi"/>
+        <a:font script="Cans" typeface="Euphemia"/>
+        <a:font script="Cher" typeface="Plantagenet Cherokee"/>
+        <a:font script="Yiii" typeface="Microsoft Yi Baiti"/>
+        <a:font script="Tibt" typeface="Microsoft Himalaya"/>
+        <a:font script="Thaa" typeface="MV Boli"/>
+        <a:font script="Deva" typeface="Mangal"/>
+        <a:font script="Telu" typeface="Gautami"/>
+        <a:font script="Taml" typeface="Latha"/>
+        <a:font script="Syrc" typeface="Estrangelo Edessa"/>
+        <a:font script="Orya" typeface="Kalinga"/>
+        <a:font script="Mlym" typeface="Kartika"/>
+        <a:font script="Laoo" typeface="DokChampa"/>
+        <a:font script="Sinh" typeface="Iskoola Pota"/>
+        <a:font script="Mong" typeface="Mongolian Baiti"/>
+        <a:font script="Viet" typeface="Times New Roman"/>
+        <a:font script="Uigh" typeface="Microsoft Uighur"/>
+        <a:font script="Geor" typeface="Sylfaen"/>
+        <a:font script="Armn" typeface="Arial"/>
+        <a:font script="Bugi" typeface="Leelawadee UI"/>
+        <a:font script="Bopo" typeface="Microsoft JhengHei"/>
+        <a:font script="Java" typeface="Javanese Text"/>
+        <a:font script="Lisu" typeface="Segoe UI"/>
+        <a:font script="Mymr" typeface="Myanmar Text"/>
+        <a:font script="Nkoo" typeface="Ebrima"/>
+        <a:font script="Olck" typeface="Nirmala UI"/>
+        <a:font script="Osma" typeface="Ebrima"/>
+        <a:font script="Phag" typeface="Phagspa"/>
+        <a:font script="Syrn" typeface="Estrangelo Edessa"/>
+        <a:font script="Syrj" typeface="Estrangelo Edessa"/>
+        <a:font script="Syre" typeface="Estrangelo Edessa"/>
+        <a:font script="Sora" typeface="Nirmala UI"/>
+        <a:font script="Tale" typeface="Microsoft Tai Le"/>
+        <a:font script="Talu" typeface="Microsoft New Tai Lue"/>
+        <a:font script="Tfng" typeface="Ebrima"/>
+      </a:majorFont>
+      <a:minorFont>
+        <a:latin typeface="Aptos" panose="02110004020202020204"/>
+        <a:ea typeface=""/>
+        <a:cs typeface=""/>
+        <a:font script="Jpan" typeface="游ゴシック"/>
+        <a:font script="Hang" typeface="맑은 고딕"/>
+        <a:font script="Hans" typeface="等线"/>
+        <a:font script="Hant" typeface="新細明體"/>
+        <a:font script="Arab" typeface="Arial"/>
+        <a:font script="Hebr" typeface="Arial"/>
+        <a:font script="Thai" typeface="Cordia New"/>
+        <a:font script="Ethi" typeface="Nyala"/>
+        <a:font script="Beng" typeface="Vrinda"/>
+        <a:font script="Gujr" typeface="Shruti"/>
+        <a:font script="Khmr" typeface="DaunPenh"/>
+        <a:font script="Knda" typeface="Tunga"/>
+        <a:font script="Guru" typeface="Raavi"/>
+        <a:font script="Cans" typeface="Euphemia"/>
+        <a:font script="Cher" typeface="Plantagenet Cherokee"/>
+        <a:font script="Yiii" typeface="Microsoft Yi Baiti"/>
+        <a:font script="Tibt" typeface="Microsoft Himalaya"/>
+        <a:font script="Thaa" typeface="MV Boli"/>
+        <a:font script="Deva" typeface="Mangal"/>
+        <a:font script="Telu" typeface="Gautami"/>
+        <a:font script="Taml" typeface="Latha"/>
+        <a:font script="Syrc" typeface="Estrangelo Edessa"/>
+        <a:font script="Orya" typeface="Kalinga"/>
+        <a:font script="Mlym" typeface="Kartika"/>
+        <a:font script="Laoo" typeface="DokChampa"/>
+        <a:font script="Sinh" typeface="Iskoola Pota"/>
+        <a:font script="Mong" typeface="Mongolian Baiti"/>
+        <a:font script="Viet" typeface="Arial"/>
+        <a:font script="Uigh" typeface="Microsoft Uighur"/>
+        <a:font script="Geor" typeface="Sylfaen"/>
+        <a:font script="Armn" typeface="Arial"/>
+        <a:font script="Bugi" typeface="Leelawadee UI"/>
+        <a:font script="Bopo" typeface="Microsoft JhengHei"/>
+        <a:font script="Java" typeface="Javanese Text"/>
+        <a:font script="Lisu" typeface="Segoe UI"/>
+        <a:font script="Mymr" typeface="Myanmar Text"/>
+        <a:font script="Nkoo" typeface="Ebrima"/>
+        <a:font script="Olck" typeface="Nirmala UI"/>
+        <a:font script="Osma" typeface="Ebrima"/>
+        <a:font script="Phag" typeface="Phagspa"/>
+        <a:font script="Syrn" typeface="Estrangelo Edessa"/>
+        <a:font script="Syrj" typeface="Estrangelo Edessa"/>
+        <a:font script="Syre" typeface="Estrangelo Edessa"/>
+        <a:font script="Sora" typeface="Nirmala UI"/>
+        <a:font script="Tale" typeface="Microsoft Tai Le"/>
+        <a:font script="Talu" typeface="Microsoft New Tai Lue"/>
+        <a:font script="Tfng" typeface="Ebrima"/>
+      </a:minorFont>
+    </a:fontScheme>
+    <a:fmtScheme name="Office">
+      <a:fillStyleLst>
+        <a:solidFill>
+          <a:schemeClr val="phClr"/>
+        </a:solidFill>
+        <a:gradFill rotWithShape="1">
+          <a:gsLst>
+            <a:gs pos="0">
+              <a:schemeClr val="phClr">
+                <a:lumMod val="110000"/>
+                <a:satMod val="105000"/>
+                <a:tint val="67000"/>
+              </a:schemeClr>
+            </a:gs>
+            <a:gs pos="50000">
+              <a:schemeClr val="phClr">
+                <a:lumMod val="105000"/>
+                <a:satMod val="103000"/>
+                <a:tint val="73000"/>
+              </a:schemeClr>
+            </a:gs>
+            <a:gs pos="100000">
+              <a:schemeClr val="phClr">
+                <a:lumMod val="105000"/>
+                <a:satMod val="109000"/>
+                <a:tint val="81000"/>
+              </a:schemeClr>
+            </a:gs>
+          </a:gsLst>
+          <a:lin ang="5400000" scaled="0"/>
+        </a:gradFill>
+        <a:gradFill rotWithShape="1">
+          <a:gsLst>
+            <a:gs pos="0">
+              <a:schemeClr val="phClr">
+                <a:satMod val="103000"/>
+                <a:lumMod val="102000"/>
+                <a:tint val="94000"/>
+              </a:schemeClr>
+            </a:gs>
+            <a:gs pos="50000">
+              <a:schemeClr val="phClr">
+                <a:satMod val="110000"/>
+                <a:lumMod val="100000"/>
+                <a:shade val="100000"/>
+              </a:schemeClr>
+            </a:gs>
+            <a:gs pos="100000">
+              <a:schemeClr val="phClr">
+                <a:lumMod val="99000"/>
+                <a:satMod val="120000"/>
+                <a:shade val="78000"/>
+              </a:schemeClr>
+            </a:gs>
+          </a:gsLst>
+          <a:lin ang="5400000" scaled="0"/>
+        </a:gradFill>
+      </a:fillStyleLst>
+      <a:lnStyleLst>
+        <a:ln w="12700" cap="flat" cmpd="sng" algn="ctr">
+          <a:solidFill>
+            <a:schemeClr val="phClr"/>
+          </a:solidFill>
+          <a:prstDash val="solid"/>
+          <a:miter lim="800000"/>
+        </a:ln>
+        <a:ln w="19050" cap="flat" cmpd="sng" algn="ctr">
+          <a:solidFill>
+            <a:schemeClr val="phClr"/>
+          </a:solidFill>
+          <a:prstDash val="solid"/>
+          <a:miter lim="800000"/>
+        </a:ln>
+        <a:ln w="25400" cap="flat" cmpd="sng" algn="ctr">
+          <a:solidFill>
+            <a:schemeClr val="phClr"/>
+          </a:solidFill>
+          <a:prstDash val="solid"/>
+          <a:miter lim="800000"/>
+        </a:ln>
+      </a:lnStyleLst>
+      <a:effectStyleLst>
+        <a:effectStyle>
+          <a:effectLst/>
+        </a:effectStyle>
+        <a:effectStyle>
+          <a:effectLst/>
+        </a:effectStyle>
+        <a:effectStyle>
+          <a:effectLst>
+            <a:outerShdw blurRad="57150" dist="19050" dir="5400000" algn="ctr" rotWithShape="0">
+              <a:srgbClr val="000000">
+                <a:alpha val="63000"/>
+              </a:srgbClr>
+            </a:outerShdw>
+          </a:effectLst>
+        </a:effectStyle>
+      </a:effectStyleLst>
+      <a:bgFillStyleLst>
+        <a:solidFill>
+          <a:schemeClr val="phClr"/>
+        </a:solidFill>
+        <a:solidFill>
+          <a:schemeClr val="phClr">
+            <a:tint val="95000"/>
+            <a:satMod val="170000"/>
+          </a:schemeClr>
+        </a:solidFill>
+        <a:gradFill rotWithShape="1">
+          <a:gsLst>
+            <a:gs pos="0">
+              <a:schemeClr val="phClr">
+                <a:tint val="93000"/>
+                <a:satMod val="150000"/>
+                <a:shade val="98000"/>
+                <a:lumMod val="102000"/>
+              </a:schemeClr>
+            </a:gs>
+            <a:gs pos="50000">
+              <a:schemeClr val="phClr">
+                <a:tint val="98000"/>
+                <a:satMod val="130000"/>
+                <a:shade val="90000"/>
+                <a:lumMod val="103000"/>
+              </a:schemeClr>
+            </a:gs>
+            <a:gs pos="100000">
+              <a:schemeClr val="phClr">
+                <a:shade val="63000"/>
+                <a:satMod val="120000"/>
+              </a:schemeClr>
+            </a:gs>
+          </a:gsLst>
+          <a:lin ang="5400000" scaled="0"/>
+        </a:gradFill>
+      </a:bgFillStyleLst>
+    </a:fmtScheme>
+  </a:themeElements>
+  <a:objectDefaults>
+    <a:lnDef>
+      <a:spPr/>
+      <a:bodyPr/>
+      <a:lstStyle/>
+      <a:style>
+        <a:lnRef idx="2">
+          <a:schemeClr val="accent1"/>
+        </a:lnRef>
+        <a:fillRef idx="0">
+          <a:schemeClr val="accent1"/>
+        </a:fillRef>
+        <a:effectRef idx="1">
+          <a:schemeClr val="accent1"/>
+        </a:effectRef>
+        <a:fontRef idx="minor">
+          <a:schemeClr val="tx1"/>
+        </a:fontRef>
+      </a:style>
+    </a:lnDef>
+  </a:objectDefaults>
+  <a:extraClrSchemeLst/>
+  <a:extLst>
+    <a:ext uri="{05A4C25C-085E-4340-85A3-A5531E510DB2}">
+      <thm15:themeFamily xmlns:thm15="http://schemas.microsoft.com/office/thememl/2012/main" name="Office Theme" id="{2E142A2C-CD16-42D6-873A-C26D2A0506FA}" vid="{1BDDFF52-6CD6-40A5-AB3C-68EB2F1E4D0A}"/>
+    </a:ext>
+  </a:extLst>
+</a:theme>
 </file>
</xml_diff>